<commit_message>
fix(recipes): feature_cards stop stretching body into empty slabs
Slide-5 failure mode was layout, not “Apple palette”: body Text nodes
used weight=1 so short copy inflated into 9–10 cm hollow frames.

Pack content top of each card (index + fixed title band + content-height
body), put free space in Spacer, drop the 0.18 cm hairline bar. Rebuild
flagship demo with tighter three-promise copy; OfficeCLI issues 0.
</commit_message>
<xml_diff>
--- a/demo/designmd-pptx-intro-v2.1.2.pptx
+++ b/demo/designmd-pptx-intro-v2.1.2.pptx
@@ -5,15 +5,15 @@
     <p:sldMasterId xmlns:r="http://schemas.openxmlformats.org/officeDocument/2006/relationships" id="2147483648" r:id="rId1"/>
   </p:sldMasterIdLst>
   <p:sldIdLst>
-    <p:sldId id="256" r:id="R69c6e182ed0a4d0b"/>
-    <p:sldId id="257" r:id="Rc153ca1fc2274570"/>
-    <p:sldId id="258" r:id="Ra0f1d6a0acf7476c"/>
-    <p:sldId id="259" r:id="R270c96efc2244cd7"/>
-    <p:sldId id="260" r:id="R30d1644b2f0b4db0"/>
-    <p:sldId id="261" r:id="R1df8e731dd134146"/>
-    <p:sldId id="262" r:id="Raa271145f4b84f78"/>
-    <p:sldId id="263" r:id="R21ed5e3909484aa7"/>
-    <p:sldId id="264" r:id="Rdeaf4a61ce614324"/>
+    <p:sldId id="256" r:id="R47e615a66ff042fd"/>
+    <p:sldId id="257" r:id="Rf28145627ea546cb"/>
+    <p:sldId id="258" r:id="R9afb6375128f411a"/>
+    <p:sldId id="259" r:id="Rbac8c35491b2455b"/>
+    <p:sldId id="260" r:id="Rac90d536fb1e4fe8"/>
+    <p:sldId id="261" r:id="R1c1710e4b29c4e4f"/>
+    <p:sldId id="262" r:id="Rc63f2729f36a4a09"/>
+    <p:sldId id="263" r:id="R5faee808785e4caa"/>
+    <p:sldId id="264" r:id="Rb600381596874e36"/>
   </p:sldIdLst>
   <p:sldSz cx="12192000" cy="6858000"/>
   <p:notesSz cx="6858000" cy="9144000"/>
@@ -2133,7 +2133,7 @@
         </p:nvSpPr>
         <p:spPr>
           <a:xfrm xmlns:a="http://schemas.openxmlformats.org/drawingml/2006/main">
-            <a:off x="792000" y="432000"/>
+            <a:off x="792000" y="486000"/>
             <a:ext cx="10609200" cy="662400"/>
           </a:xfrm>
           <a:prstGeom xmlns:a="http://schemas.openxmlformats.org/drawingml/2006/main" prst="rect">
@@ -2153,7 +2153,7 @@
                 <a:latin typeface="Arial"/>
                 <a:ea typeface="Arial"/>
               </a:rPr>
-              <a:t>What you get</a:t>
+              <a:t>Three promises</a:t>
             </a:r>
           </a:p>
         </p:txBody>
@@ -2166,8 +2166,8 @@
         </p:nvSpPr>
         <p:spPr>
           <a:xfrm xmlns:a="http://schemas.openxmlformats.org/drawingml/2006/main">
-            <a:off x="792000" y="1418400"/>
-            <a:ext cx="3272400" cy="5079600"/>
+            <a:off x="792000" y="1490400"/>
+            <a:ext cx="3272400" cy="4935600"/>
           </a:xfrm>
           <a:prstGeom xmlns:a="http://schemas.openxmlformats.org/drawingml/2006/main" prst="roundRect">
             <a:avLst/>
@@ -2176,9 +2176,7 @@
             <a:srgbClr val="1C1C1E"/>
           </a:solidFill>
           <a:ln xmlns:a="http://schemas.openxmlformats.org/drawingml/2006/main">
-            <a:solidFill>
-              <a:srgbClr val="3A3A3C"/>
-            </a:solidFill>
+            <a:noFill/>
           </a:ln>
         </p:spPr>
         <p:txBody>
@@ -2189,20 +2187,119 @@
       </p:sp>
       <p:sp>
         <p:nvSpPr>
-          <p:cNvPr id="100027" name="Card1Accent"/>
+          <p:cNvPr id="100027" name="Card1Num"/>
+          <p:cNvSpPr txBox="1"/>
+          <p:nvPr/>
+        </p:nvSpPr>
+        <p:spPr>
+          <a:xfrm xmlns:a="http://schemas.openxmlformats.org/drawingml/2006/main">
+            <a:off x="1098000" y="1958400"/>
+            <a:ext cx="2660400" cy="684000"/>
+          </a:xfrm>
+          <a:prstGeom xmlns:a="http://schemas.openxmlformats.org/drawingml/2006/main" prst="rect">
+            <a:avLst/>
+          </a:prstGeom>
+          <a:noFill xmlns:a="http://schemas.openxmlformats.org/drawingml/2006/main"/>
+        </p:spPr>
+        <p:txBody>
+          <a:bodyPr xmlns:a="http://schemas.openxmlformats.org/drawingml/2006/main"/>
+          <a:lstStyle xmlns:a="http://schemas.openxmlformats.org/drawingml/2006/main"/>
+          <a:p xmlns:a="http://schemas.openxmlformats.org/drawingml/2006/main">
+            <a:r>
+              <a:rPr lang="en-US" sz="3400" b="1">
+                <a:solidFill>
+                  <a:srgbClr val="0B5FFF"/>
+                </a:solidFill>
+                <a:latin typeface="Arial"/>
+                <a:ea typeface="Arial"/>
+              </a:rPr>
+              <a:t>01</a:t>
+            </a:r>
+          </a:p>
+        </p:txBody>
+      </p:sp>
+      <p:sp>
+        <p:nvSpPr>
+          <p:cNvPr id="100028" name="Card1Title"/>
+          <p:cNvSpPr txBox="1"/>
+          <p:nvPr/>
+        </p:nvSpPr>
+        <p:spPr>
+          <a:xfrm xmlns:a="http://schemas.openxmlformats.org/drawingml/2006/main">
+            <a:off x="1098000" y="2804400"/>
+            <a:ext cx="2660400" cy="1008000"/>
+          </a:xfrm>
+          <a:prstGeom xmlns:a="http://schemas.openxmlformats.org/drawingml/2006/main" prst="rect">
+            <a:avLst/>
+          </a:prstGeom>
+          <a:noFill xmlns:a="http://schemas.openxmlformats.org/drawingml/2006/main"/>
+        </p:spPr>
+        <p:txBody>
+          <a:bodyPr xmlns:a="http://schemas.openxmlformats.org/drawingml/2006/main"/>
+          <a:lstStyle xmlns:a="http://schemas.openxmlformats.org/drawingml/2006/main"/>
+          <a:p xmlns:a="http://schemas.openxmlformats.org/drawingml/2006/main">
+            <a:r>
+              <a:rPr lang="en-US" sz="2600" b="1">
+                <a:solidFill>
+                  <a:srgbClr val="F5F5F7"/>
+                </a:solidFill>
+                <a:latin typeface="Arial"/>
+                <a:ea typeface="Arial"/>
+              </a:rPr>
+              <a:t>Exact geometry</a:t>
+            </a:r>
+          </a:p>
+        </p:txBody>
+      </p:sp>
+      <p:sp>
+        <p:nvSpPr>
+          <p:cNvPr id="100029" name="Card1Body"/>
+          <p:cNvSpPr txBox="1"/>
+          <p:nvPr/>
+        </p:nvSpPr>
+        <p:spPr>
+          <a:xfrm xmlns:a="http://schemas.openxmlformats.org/drawingml/2006/main">
+            <a:off x="1098000" y="3974400"/>
+            <a:ext cx="2660400" cy="946800"/>
+          </a:xfrm>
+          <a:prstGeom xmlns:a="http://schemas.openxmlformats.org/drawingml/2006/main" prst="rect">
+            <a:avLst/>
+          </a:prstGeom>
+          <a:noFill xmlns:a="http://schemas.openxmlformats.org/drawingml/2006/main"/>
+        </p:spPr>
+        <p:txBody>
+          <a:bodyPr xmlns:a="http://schemas.openxmlformats.org/drawingml/2006/main"/>
+          <a:lstStyle xmlns:a="http://schemas.openxmlformats.org/drawingml/2006/main"/>
+          <a:p xmlns:a="http://schemas.openxmlformats.org/drawingml/2006/main">
+            <a:r>
+              <a:rPr lang="en-US" sz="1800">
+                <a:solidFill>
+                  <a:srgbClr val="A0A6B0"/>
+                </a:solidFill>
+                <a:latin typeface="Arial"/>
+                <a:ea typeface="Arial"/>
+              </a:rPr>
+              <a:t>Centimeters. Glued connectors. Type floors that hold.</a:t>
+            </a:r>
+          </a:p>
+        </p:txBody>
+      </p:sp>
+      <p:sp>
+        <p:nvSpPr>
+          <p:cNvPr id="100030" name="Card2Bg"/>
           <p:cNvSpPr/>
           <p:nvPr/>
         </p:nvSpPr>
         <p:spPr>
           <a:xfrm xmlns:a="http://schemas.openxmlformats.org/drawingml/2006/main">
-            <a:off x="792000" y="1418400"/>
-            <a:ext cx="3272400" cy="64800"/>
-          </a:xfrm>
-          <a:prstGeom xmlns:a="http://schemas.openxmlformats.org/drawingml/2006/main" prst="rect">
+            <a:off x="4460400" y="1490400"/>
+            <a:ext cx="3272400" cy="4935600"/>
+          </a:xfrm>
+          <a:prstGeom xmlns:a="http://schemas.openxmlformats.org/drawingml/2006/main" prst="roundRect">
             <a:avLst/>
           </a:prstGeom>
           <a:solidFill xmlns:a="http://schemas.openxmlformats.org/drawingml/2006/main">
-            <a:srgbClr val="0B5FFF"/>
+            <a:srgbClr val="1C1C1E"/>
           </a:solidFill>
           <a:ln xmlns:a="http://schemas.openxmlformats.org/drawingml/2006/main">
             <a:noFill/>
@@ -2216,14 +2313,14 @@
       </p:sp>
       <p:sp>
         <p:nvSpPr>
-          <p:cNvPr id="100028" name="Card1Title"/>
+          <p:cNvPr id="100031" name="Card2Num"/>
           <p:cNvSpPr txBox="1"/>
           <p:nvPr/>
         </p:nvSpPr>
         <p:spPr>
           <a:xfrm xmlns:a="http://schemas.openxmlformats.org/drawingml/2006/main">
-            <a:off x="1008000" y="1843200"/>
-            <a:ext cx="2840400" cy="979200"/>
+            <a:off x="4766400" y="1958400"/>
+            <a:ext cx="2660400" cy="684000"/>
           </a:xfrm>
           <a:prstGeom xmlns:a="http://schemas.openxmlformats.org/drawingml/2006/main" prst="rect">
             <a:avLst/>
@@ -2235,28 +2332,28 @@
           <a:lstStyle xmlns:a="http://schemas.openxmlformats.org/drawingml/2006/main"/>
           <a:p xmlns:a="http://schemas.openxmlformats.org/drawingml/2006/main">
             <a:r>
-              <a:rPr lang="en-US" sz="2800" b="1">
-                <a:solidFill>
-                  <a:srgbClr val="F5F5F7"/>
-                </a:solidFill>
-                <a:latin typeface="Arial"/>
-                <a:ea typeface="Arial"/>
-              </a:rPr>
-              <a:t>Precise geometry</a:t>
-            </a:r>
-          </a:p>
-        </p:txBody>
-      </p:sp>
-      <p:sp>
-        <p:nvSpPr>
-          <p:cNvPr id="100029" name="Card1Body"/>
+              <a:rPr lang="en-US" sz="3400" b="1">
+                <a:solidFill>
+                  <a:srgbClr val="0B5FFF"/>
+                </a:solidFill>
+                <a:latin typeface="Arial"/>
+                <a:ea typeface="Arial"/>
+              </a:rPr>
+              <a:t>02</a:t>
+            </a:r>
+          </a:p>
+        </p:txBody>
+      </p:sp>
+      <p:sp>
+        <p:nvSpPr>
+          <p:cNvPr id="100032" name="Card2Title"/>
           <p:cNvSpPr txBox="1"/>
           <p:nvPr/>
         </p:nvSpPr>
         <p:spPr>
           <a:xfrm xmlns:a="http://schemas.openxmlformats.org/drawingml/2006/main">
-            <a:off x="1008000" y="3002400"/>
-            <a:ext cx="2840400" cy="3279600"/>
+            <a:off x="4766400" y="2804400"/>
+            <a:ext cx="2660400" cy="1008000"/>
           </a:xfrm>
           <a:prstGeom xmlns:a="http://schemas.openxmlformats.org/drawingml/2006/main" prst="rect">
             <a:avLst/>
@@ -2268,6 +2365,39 @@
           <a:lstStyle xmlns:a="http://schemas.openxmlformats.org/drawingml/2006/main"/>
           <a:p xmlns:a="http://schemas.openxmlformats.org/drawingml/2006/main">
             <a:r>
+              <a:rPr lang="en-US" sz="2600" b="1">
+                <a:solidFill>
+                  <a:srgbClr val="F5F5F7"/>
+                </a:solidFill>
+                <a:latin typeface="Arial"/>
+                <a:ea typeface="Arial"/>
+              </a:rPr>
+              <a:t>Hard gates</a:t>
+            </a:r>
+          </a:p>
+        </p:txBody>
+      </p:sp>
+      <p:sp>
+        <p:nvSpPr>
+          <p:cNvPr id="100033" name="Card2Body"/>
+          <p:cNvSpPr txBox="1"/>
+          <p:nvPr/>
+        </p:nvSpPr>
+        <p:spPr>
+          <a:xfrm xmlns:a="http://schemas.openxmlformats.org/drawingml/2006/main">
+            <a:off x="4766400" y="3974400"/>
+            <a:ext cx="2660400" cy="946800"/>
+          </a:xfrm>
+          <a:prstGeom xmlns:a="http://schemas.openxmlformats.org/drawingml/2006/main" prst="rect">
+            <a:avLst/>
+          </a:prstGeom>
+          <a:noFill xmlns:a="http://schemas.openxmlformats.org/drawingml/2006/main"/>
+        </p:spPr>
+        <p:txBody>
+          <a:bodyPr xmlns:a="http://schemas.openxmlformats.org/drawingml/2006/main"/>
+          <a:lstStyle xmlns:a="http://schemas.openxmlformats.org/drawingml/2006/main"/>
+          <a:p xmlns:a="http://schemas.openxmlformats.org/drawingml/2006/main">
+            <a:r>
               <a:rPr lang="en-US" sz="1800">
                 <a:solidFill>
                   <a:srgbClr val="A0A6B0"/>
@@ -2275,21 +2405,21 @@
                 <a:latin typeface="Arial"/>
                 <a:ea typeface="Arial"/>
               </a:rPr>
-              <a:t>Shape-level apply from recipes — cm layout, connectors, brand fonts and floors.</a:t>
-            </a:r>
-          </a:p>
-        </p:txBody>
-      </p:sp>
-      <p:sp>
-        <p:nvSpPr>
-          <p:cNvPr id="100030" name="Card2Bg"/>
+              <a:t>Budgets, contrast, issues — then a contact sheet.</a:t>
+            </a:r>
+          </a:p>
+        </p:txBody>
+      </p:sp>
+      <p:sp>
+        <p:nvSpPr>
+          <p:cNvPr id="100034" name="Card3Bg"/>
           <p:cNvSpPr/>
           <p:nvPr/>
         </p:nvSpPr>
         <p:spPr>
           <a:xfrm xmlns:a="http://schemas.openxmlformats.org/drawingml/2006/main">
-            <a:off x="4460400" y="1418400"/>
-            <a:ext cx="3272400" cy="5079600"/>
+            <a:off x="8128800" y="1490400"/>
+            <a:ext cx="3272400" cy="4935600"/>
           </a:xfrm>
           <a:prstGeom xmlns:a="http://schemas.openxmlformats.org/drawingml/2006/main" prst="roundRect">
             <a:avLst/>
@@ -2298,35 +2428,6 @@
             <a:srgbClr val="1C1C1E"/>
           </a:solidFill>
           <a:ln xmlns:a="http://schemas.openxmlformats.org/drawingml/2006/main">
-            <a:solidFill>
-              <a:srgbClr val="3A3A3C"/>
-            </a:solidFill>
-          </a:ln>
-        </p:spPr>
-        <p:txBody>
-          <a:bodyPr xmlns:a="http://schemas.openxmlformats.org/drawingml/2006/main"/>
-          <a:lstStyle xmlns:a="http://schemas.openxmlformats.org/drawingml/2006/main"/>
-          <a:p xmlns:a="http://schemas.openxmlformats.org/drawingml/2006/main"/>
-        </p:txBody>
-      </p:sp>
-      <p:sp>
-        <p:nvSpPr>
-          <p:cNvPr id="100031" name="Card2Accent"/>
-          <p:cNvSpPr/>
-          <p:nvPr/>
-        </p:nvSpPr>
-        <p:spPr>
-          <a:xfrm xmlns:a="http://schemas.openxmlformats.org/drawingml/2006/main">
-            <a:off x="4460400" y="1418400"/>
-            <a:ext cx="3272400" cy="64800"/>
-          </a:xfrm>
-          <a:prstGeom xmlns:a="http://schemas.openxmlformats.org/drawingml/2006/main" prst="rect">
-            <a:avLst/>
-          </a:prstGeom>
-          <a:solidFill xmlns:a="http://schemas.openxmlformats.org/drawingml/2006/main">
-            <a:srgbClr val="0B5FFF"/>
-          </a:solidFill>
-          <a:ln xmlns:a="http://schemas.openxmlformats.org/drawingml/2006/main">
             <a:noFill/>
           </a:ln>
         </p:spPr>
@@ -2338,14 +2439,14 @@
       </p:sp>
       <p:sp>
         <p:nvSpPr>
-          <p:cNvPr id="100032" name="Card2Title"/>
+          <p:cNvPr id="100035" name="Card3Num"/>
           <p:cNvSpPr txBox="1"/>
           <p:nvPr/>
         </p:nvSpPr>
         <p:spPr>
           <a:xfrm xmlns:a="http://schemas.openxmlformats.org/drawingml/2006/main">
-            <a:off x="4676400" y="1843200"/>
-            <a:ext cx="2840400" cy="536400"/>
+            <a:off x="8434800" y="1958400"/>
+            <a:ext cx="2660400" cy="684000"/>
           </a:xfrm>
           <a:prstGeom xmlns:a="http://schemas.openxmlformats.org/drawingml/2006/main" prst="rect">
             <a:avLst/>
@@ -2357,105 +2458,16 @@
           <a:lstStyle xmlns:a="http://schemas.openxmlformats.org/drawingml/2006/main"/>
           <a:p xmlns:a="http://schemas.openxmlformats.org/drawingml/2006/main">
             <a:r>
-              <a:rPr lang="en-US" sz="2800" b="1">
-                <a:solidFill>
-                  <a:srgbClr val="F5F5F7"/>
-                </a:solidFill>
-                <a:latin typeface="Arial"/>
-                <a:ea typeface="Arial"/>
-              </a:rPr>
-              <a:t>Quality gates</a:t>
-            </a:r>
-          </a:p>
-        </p:txBody>
-      </p:sp>
-      <p:sp>
-        <p:nvSpPr>
-          <p:cNvPr id="100033" name="Card2Body"/>
-          <p:cNvSpPr txBox="1"/>
-          <p:nvPr/>
-        </p:nvSpPr>
-        <p:spPr>
-          <a:xfrm xmlns:a="http://schemas.openxmlformats.org/drawingml/2006/main">
-            <a:off x="4676400" y="2556000"/>
-            <a:ext cx="2840400" cy="3726000"/>
-          </a:xfrm>
-          <a:prstGeom xmlns:a="http://schemas.openxmlformats.org/drawingml/2006/main" prst="rect">
-            <a:avLst/>
-          </a:prstGeom>
-          <a:noFill xmlns:a="http://schemas.openxmlformats.org/drawingml/2006/main"/>
-        </p:spPr>
-        <p:txBody>
-          <a:bodyPr xmlns:a="http://schemas.openxmlformats.org/drawingml/2006/main"/>
-          <a:lstStyle xmlns:a="http://schemas.openxmlformats.org/drawingml/2006/main"/>
-          <a:p xmlns:a="http://schemas.openxmlformats.org/drawingml/2006/main">
-            <a:r>
-              <a:rPr lang="en-US" sz="1800">
-                <a:solidFill>
-                  <a:srgbClr val="A0A6B0"/>
-                </a:solidFill>
-                <a:latin typeface="Arial"/>
-                <a:ea typeface="Arial"/>
-              </a:rPr>
-              <a:t>Text budgets, contrast, staging issues, and Gate 3 screenshots before delivery.</a:t>
-            </a:r>
-          </a:p>
-        </p:txBody>
-      </p:sp>
-      <p:sp>
-        <p:nvSpPr>
-          <p:cNvPr id="100034" name="Card3Bg"/>
-          <p:cNvSpPr/>
-          <p:nvPr/>
-        </p:nvSpPr>
-        <p:spPr>
-          <a:xfrm xmlns:a="http://schemas.openxmlformats.org/drawingml/2006/main">
-            <a:off x="8128800" y="1418400"/>
-            <a:ext cx="3272400" cy="5079600"/>
-          </a:xfrm>
-          <a:prstGeom xmlns:a="http://schemas.openxmlformats.org/drawingml/2006/main" prst="roundRect">
-            <a:avLst/>
-          </a:prstGeom>
-          <a:solidFill xmlns:a="http://schemas.openxmlformats.org/drawingml/2006/main">
-            <a:srgbClr val="1C1C1E"/>
-          </a:solidFill>
-          <a:ln xmlns:a="http://schemas.openxmlformats.org/drawingml/2006/main">
-            <a:solidFill>
-              <a:srgbClr val="3A3A3C"/>
-            </a:solidFill>
-          </a:ln>
-        </p:spPr>
-        <p:txBody>
-          <a:bodyPr xmlns:a="http://schemas.openxmlformats.org/drawingml/2006/main"/>
-          <a:lstStyle xmlns:a="http://schemas.openxmlformats.org/drawingml/2006/main"/>
-          <a:p xmlns:a="http://schemas.openxmlformats.org/drawingml/2006/main"/>
-        </p:txBody>
-      </p:sp>
-      <p:sp>
-        <p:nvSpPr>
-          <p:cNvPr id="100035" name="Card3Accent"/>
-          <p:cNvSpPr/>
-          <p:nvPr/>
-        </p:nvSpPr>
-        <p:spPr>
-          <a:xfrm xmlns:a="http://schemas.openxmlformats.org/drawingml/2006/main">
-            <a:off x="8128800" y="1418400"/>
-            <a:ext cx="3272400" cy="64800"/>
-          </a:xfrm>
-          <a:prstGeom xmlns:a="http://schemas.openxmlformats.org/drawingml/2006/main" prst="rect">
-            <a:avLst/>
-          </a:prstGeom>
-          <a:solidFill xmlns:a="http://schemas.openxmlformats.org/drawingml/2006/main">
-            <a:srgbClr val="0B5FFF"/>
-          </a:solidFill>
-          <a:ln xmlns:a="http://schemas.openxmlformats.org/drawingml/2006/main">
-            <a:noFill/>
-          </a:ln>
-        </p:spPr>
-        <p:txBody>
-          <a:bodyPr xmlns:a="http://schemas.openxmlformats.org/drawingml/2006/main"/>
-          <a:lstStyle xmlns:a="http://schemas.openxmlformats.org/drawingml/2006/main"/>
-          <a:p xmlns:a="http://schemas.openxmlformats.org/drawingml/2006/main"/>
+              <a:rPr lang="en-US" sz="3400" b="1">
+                <a:solidFill>
+                  <a:srgbClr val="0B5FFF"/>
+                </a:solidFill>
+                <a:latin typeface="Arial"/>
+                <a:ea typeface="Arial"/>
+              </a:rPr>
+              <a:t>03</a:t>
+            </a:r>
+          </a:p>
         </p:txBody>
       </p:sp>
       <p:sp>
@@ -2466,8 +2478,8 @@
         </p:nvSpPr>
         <p:spPr>
           <a:xfrm xmlns:a="http://schemas.openxmlformats.org/drawingml/2006/main">
-            <a:off x="8344800" y="1843200"/>
-            <a:ext cx="2840400" cy="536400"/>
+            <a:off x="8434800" y="2804400"/>
+            <a:ext cx="2660400" cy="1008000"/>
           </a:xfrm>
           <a:prstGeom xmlns:a="http://schemas.openxmlformats.org/drawingml/2006/main" prst="rect">
             <a:avLst/>
@@ -2479,14 +2491,14 @@
           <a:lstStyle xmlns:a="http://schemas.openxmlformats.org/drawingml/2006/main"/>
           <a:p xmlns:a="http://schemas.openxmlformats.org/drawingml/2006/main">
             <a:r>
-              <a:rPr lang="en-US" sz="2800" b="1">
-                <a:solidFill>
-                  <a:srgbClr val="F5F5F7"/>
-                </a:solidFill>
-                <a:latin typeface="Arial"/>
-                <a:ea typeface="Arial"/>
-              </a:rPr>
-              <a:t>Agent-ready</a:t>
+              <a:rPr lang="en-US" sz="2600" b="1">
+                <a:solidFill>
+                  <a:srgbClr val="F5F5F7"/>
+                </a:solidFill>
+                <a:latin typeface="Arial"/>
+                <a:ea typeface="Arial"/>
+              </a:rPr>
+              <a:t>Agent-safe</a:t>
             </a:r>
           </a:p>
         </p:txBody>
@@ -2499,8 +2511,8 @@
         </p:nvSpPr>
         <p:spPr>
           <a:xfrm xmlns:a="http://schemas.openxmlformats.org/drawingml/2006/main">
-            <a:off x="8344800" y="2556000"/>
-            <a:ext cx="2840400" cy="3726000"/>
+            <a:off x="8434800" y="3974400"/>
+            <a:ext cx="2660400" cy="946800"/>
           </a:xfrm>
           <a:prstGeom xmlns:a="http://schemas.openxmlformats.org/drawingml/2006/main" prst="rect">
             <a:avLst/>
@@ -2519,7 +2531,7 @@
                 <a:latin typeface="Arial"/>
                 <a:ea typeface="Arial"/>
               </a:rPr>
-              <a:t>Claude, Codex, and Grok skills. Doctor asks before installing OfficeCLI.</a:t>
+              <a:t>Claude, Codex, Grok. Install only after you say yes.</a:t>
             </a:r>
           </a:p>
         </p:txBody>

</xml_diff>

<commit_message>
fix(recipes): before/after spacing from content, not canvas fill
Slide 3 was two 13.8 cm slabs with a 10.5 cm hollow body box and a
hard-coded 0.5 cm column gap — margins and size were ignored.

Size panels from pad + head + line-count body; column gap follows design
gap; inner pad tracks margin; bottom stage margin matches side margin;
settle the pair in the remaining band so cards neither flood the slide
nor float in the top third.
</commit_message>
<xml_diff>
--- a/demo/designmd-pptx-intro-v2.1.2.pptx
+++ b/demo/designmd-pptx-intro-v2.1.2.pptx
@@ -5,15 +5,15 @@
     <p:sldMasterId xmlns:r="http://schemas.openxmlformats.org/officeDocument/2006/relationships" id="2147483648" r:id="rId1"/>
   </p:sldMasterIdLst>
   <p:sldIdLst>
-    <p:sldId id="256" r:id="R47e615a66ff042fd"/>
-    <p:sldId id="257" r:id="Rf28145627ea546cb"/>
-    <p:sldId id="258" r:id="R9afb6375128f411a"/>
-    <p:sldId id="259" r:id="Rbac8c35491b2455b"/>
-    <p:sldId id="260" r:id="Rac90d536fb1e4fe8"/>
-    <p:sldId id="261" r:id="R1c1710e4b29c4e4f"/>
-    <p:sldId id="262" r:id="Rc63f2729f36a4a09"/>
-    <p:sldId id="263" r:id="R5faee808785e4caa"/>
-    <p:sldId id="264" r:id="Rb600381596874e36"/>
+    <p:sldId id="256" r:id="R5a02e6953f0e4e5b"/>
+    <p:sldId id="257" r:id="R288a9a25afe74a19"/>
+    <p:sldId id="258" r:id="R818dc887d0a94d87"/>
+    <p:sldId id="259" r:id="R0428f946ec5d4104"/>
+    <p:sldId id="260" r:id="Rd6f003f1943b4529"/>
+    <p:sldId id="261" r:id="R71e29f74ef3f4955"/>
+    <p:sldId id="262" r:id="Rd5b2638803654ce2"/>
+    <p:sldId id="263" r:id="R526b9d7a584d4b61"/>
+    <p:sldId id="264" r:id="R1978b9a3fdf04e2e"/>
   </p:sldIdLst>
   <p:sldSz cx="12192000" cy="6858000"/>
   <p:notesSz cx="6858000" cy="9144000"/>
@@ -1136,8 +1136,8 @@
         </p:nvSpPr>
         <p:spPr>
           <a:xfrm xmlns:a="http://schemas.openxmlformats.org/drawingml/2006/main">
-            <a:off x="792000" y="360000"/>
-            <a:ext cx="10609200" cy="648000"/>
+            <a:off x="792000" y="435600"/>
+            <a:ext cx="10609200" cy="594000"/>
           </a:xfrm>
           <a:prstGeom xmlns:a="http://schemas.openxmlformats.org/drawingml/2006/main" prst="rect">
             <a:avLst/>
@@ -1169,8 +1169,8 @@
         </p:nvSpPr>
         <p:spPr>
           <a:xfrm xmlns:a="http://schemas.openxmlformats.org/drawingml/2006/main">
-            <a:off x="792000" y="1260000"/>
-            <a:ext cx="5212800" cy="4968000"/>
+            <a:off x="792000" y="1965600"/>
+            <a:ext cx="5104800" cy="3153600"/>
           </a:xfrm>
           <a:prstGeom xmlns:a="http://schemas.openxmlformats.org/drawingml/2006/main" prst="roundRect">
             <a:avLst/>
@@ -1196,8 +1196,8 @@
         </p:nvSpPr>
         <p:spPr>
           <a:xfrm xmlns:a="http://schemas.openxmlformats.org/drawingml/2006/main">
-            <a:off x="972000" y="1440000"/>
-            <a:ext cx="4852800" cy="504000"/>
+            <a:off x="1227600" y="2401200"/>
+            <a:ext cx="4233600" cy="558000"/>
           </a:xfrm>
           <a:prstGeom xmlns:a="http://schemas.openxmlformats.org/drawingml/2006/main" prst="rect">
             <a:avLst/>
@@ -1216,7 +1216,7 @@
                 <a:latin typeface="Arial"/>
                 <a:ea typeface="Arial"/>
               </a:rPr>
-              <a:t>Without</a:t>
+              <a:t>Before</a:t>
             </a:r>
           </a:p>
         </p:txBody>
@@ -1229,8 +1229,8 @@
         </p:nvSpPr>
         <p:spPr>
           <a:xfrm xmlns:a="http://schemas.openxmlformats.org/drawingml/2006/main">
-            <a:off x="972000" y="2088000"/>
-            <a:ext cx="4852800" cy="3780000"/>
+            <a:off x="1227600" y="3157200"/>
+            <a:ext cx="4233600" cy="1526400"/>
           </a:xfrm>
           <a:prstGeom xmlns:a="http://schemas.openxmlformats.org/drawingml/2006/main" prst="rect">
             <a:avLst/>
@@ -1249,7 +1249,7 @@
                 <a:latin typeface="Arial"/>
                 <a:ea typeface="Arial"/>
               </a:rPr>
-              <a:t>• Hand-built decks drift from brand</a:t>
+              <a:t>• Decks drift from the brand file</a:t>
             </a:r>
           </a:p>
           <a:p xmlns:a="http://schemas.openxmlformats.org/drawingml/2006/main">
@@ -1298,8 +1298,8 @@
         </p:nvSpPr>
         <p:spPr>
           <a:xfrm xmlns:a="http://schemas.openxmlformats.org/drawingml/2006/main">
-            <a:off x="6184800" y="1260000"/>
-            <a:ext cx="5212800" cy="4968000"/>
+            <a:off x="6292800" y="1965600"/>
+            <a:ext cx="5104800" cy="3153600"/>
           </a:xfrm>
           <a:prstGeom xmlns:a="http://schemas.openxmlformats.org/drawingml/2006/main" prst="roundRect">
             <a:avLst/>
@@ -1325,8 +1325,8 @@
         </p:nvSpPr>
         <p:spPr>
           <a:xfrm xmlns:a="http://schemas.openxmlformats.org/drawingml/2006/main">
-            <a:off x="6364800" y="1440000"/>
-            <a:ext cx="4852800" cy="504000"/>
+            <a:off x="6732000" y="2401200"/>
+            <a:ext cx="4233600" cy="558000"/>
           </a:xfrm>
           <a:prstGeom xmlns:a="http://schemas.openxmlformats.org/drawingml/2006/main" prst="rect">
             <a:avLst/>
@@ -1345,7 +1345,7 @@
                 <a:latin typeface="Arial"/>
                 <a:ea typeface="Arial"/>
               </a:rPr>
-              <a:t>With designmd-pptx</a:t>
+              <a:t>After</a:t>
             </a:r>
           </a:p>
         </p:txBody>
@@ -1358,8 +1358,8 @@
         </p:nvSpPr>
         <p:spPr>
           <a:xfrm xmlns:a="http://schemas.openxmlformats.org/drawingml/2006/main">
-            <a:off x="6364800" y="2088000"/>
-            <a:ext cx="4852800" cy="3780000"/>
+            <a:off x="6732000" y="3157200"/>
+            <a:ext cx="4233600" cy="1526400"/>
           </a:xfrm>
           <a:prstGeom xmlns:a="http://schemas.openxmlformats.org/drawingml/2006/main" prst="rect">
             <a:avLst/>
@@ -1378,7 +1378,7 @@
                 <a:latin typeface="Arial"/>
                 <a:ea typeface="Arial"/>
               </a:rPr>
-              <a:t>• Compiled tokens from DESIGN.md</a:t>
+              <a:t>• Tokens compiled from DESIGN.md</a:t>
             </a:r>
           </a:p>
           <a:p xmlns:a="http://schemas.openxmlformats.org/drawingml/2006/main">
@@ -1390,7 +1390,7 @@
                 <a:latin typeface="Arial"/>
                 <a:ea typeface="Arial"/>
               </a:rPr>
-              <a:t>• Recipe catalog with text budgets</a:t>
+              <a:t>• Recipes with real text budgets</a:t>
             </a:r>
           </a:p>
           <a:p xmlns:a="http://schemas.openxmlformats.org/drawingml/2006/main">

</xml_diff>

<commit_message>
feat(ui-kit): shared StageMetrics card/stack/comparison contract
Introduce designmd_pptx.ui_kit as a React-like spacing system so recipes
stop inventing fixed cm slabs and weight-stretched text boxes.

- StageMetrics: margin/gap/pad/title bands from tokens + density
- feature_card / card / titled_stage / equal_columns / solve_stage
- comparison_panels for before/after (content-height, stage air)
- Migrate feature_cards, bullets, comparison_2col, before_after,
  close, big_number, process, _title_op
- docs/ui-kit.md + contract tests; rebuild flagship demo (issues 0)
</commit_message>
<xml_diff>
--- a/demo/designmd-pptx-intro-v2.1.2.pptx
+++ b/demo/designmd-pptx-intro-v2.1.2.pptx
@@ -5,15 +5,15 @@
     <p:sldMasterId xmlns:r="http://schemas.openxmlformats.org/officeDocument/2006/relationships" id="2147483648" r:id="rId1"/>
   </p:sldMasterIdLst>
   <p:sldIdLst>
-    <p:sldId id="256" r:id="R5a02e6953f0e4e5b"/>
-    <p:sldId id="257" r:id="R288a9a25afe74a19"/>
-    <p:sldId id="258" r:id="R818dc887d0a94d87"/>
-    <p:sldId id="259" r:id="R0428f946ec5d4104"/>
-    <p:sldId id="260" r:id="Rd6f003f1943b4529"/>
-    <p:sldId id="261" r:id="R71e29f74ef3f4955"/>
-    <p:sldId id="262" r:id="Rd5b2638803654ce2"/>
-    <p:sldId id="263" r:id="R526b9d7a584d4b61"/>
-    <p:sldId id="264" r:id="R1978b9a3fdf04e2e"/>
+    <p:sldId id="256" r:id="R614123432d444c07"/>
+    <p:sldId id="257" r:id="Rf8453ea318854e16"/>
+    <p:sldId id="258" r:id="R65faa2c9d32d41a7"/>
+    <p:sldId id="259" r:id="Rd41056334a704d99"/>
+    <p:sldId id="260" r:id="Rdfe49b9966374693"/>
+    <p:sldId id="261" r:id="Rc24419b3ada642b9"/>
+    <p:sldId id="262" r:id="Rbd524f50dafd4511"/>
+    <p:sldId id="263" r:id="R1e8254baba78415c"/>
+    <p:sldId id="264" r:id="R4f9601df485a4b5a"/>
   </p:sldIdLst>
   <p:sldSz cx="12192000" cy="6858000"/>
   <p:notesSz cx="6858000" cy="9144000"/>
@@ -910,8 +910,8 @@
         </p:nvSpPr>
         <p:spPr>
           <a:xfrm xmlns:a="http://schemas.openxmlformats.org/drawingml/2006/main">
-            <a:off x="792000" y="1368000"/>
-            <a:ext cx="10609200" cy="2592000"/>
+            <a:off x="792000" y="1180800"/>
+            <a:ext cx="10609200" cy="2304000"/>
           </a:xfrm>
           <a:prstGeom xmlns:a="http://schemas.openxmlformats.org/drawingml/2006/main" prst="rect">
             <a:avLst/>
@@ -944,8 +944,8 @@
         </p:nvSpPr>
         <p:spPr>
           <a:xfrm xmlns:a="http://schemas.openxmlformats.org/drawingml/2006/main">
-            <a:off x="792000" y="4104000"/>
-            <a:ext cx="10609200" cy="648000"/>
+            <a:off x="792000" y="3704400"/>
+            <a:ext cx="10609200" cy="612000"/>
           </a:xfrm>
           <a:prstGeom xmlns:a="http://schemas.openxmlformats.org/drawingml/2006/main" prst="rect">
             <a:avLst/>
@@ -978,8 +978,8 @@
         </p:nvSpPr>
         <p:spPr>
           <a:xfrm xmlns:a="http://schemas.openxmlformats.org/drawingml/2006/main">
-            <a:off x="1512000" y="4824000"/>
-            <a:ext cx="9169200" cy="864000"/>
+            <a:off x="1188000" y="4514400"/>
+            <a:ext cx="9817200" cy="792000"/>
           </a:xfrm>
           <a:prstGeom xmlns:a="http://schemas.openxmlformats.org/drawingml/2006/main" prst="rect">
             <a:avLst/>
@@ -1137,7 +1137,7 @@
         <p:spPr>
           <a:xfrm xmlns:a="http://schemas.openxmlformats.org/drawingml/2006/main">
             <a:off x="792000" y="435600"/>
-            <a:ext cx="10609200" cy="594000"/>
+            <a:ext cx="10609200" cy="558000"/>
           </a:xfrm>
           <a:prstGeom xmlns:a="http://schemas.openxmlformats.org/drawingml/2006/main" prst="rect">
             <a:avLst/>
@@ -1169,8 +1169,8 @@
         </p:nvSpPr>
         <p:spPr>
           <a:xfrm xmlns:a="http://schemas.openxmlformats.org/drawingml/2006/main">
-            <a:off x="792000" y="1965600"/>
-            <a:ext cx="5104800" cy="3153600"/>
+            <a:off x="792000" y="1976400"/>
+            <a:ext cx="5104800" cy="3034800"/>
           </a:xfrm>
           <a:prstGeom xmlns:a="http://schemas.openxmlformats.org/drawingml/2006/main" prst="roundRect">
             <a:avLst/>
@@ -1196,8 +1196,8 @@
         </p:nvSpPr>
         <p:spPr>
           <a:xfrm xmlns:a="http://schemas.openxmlformats.org/drawingml/2006/main">
-            <a:off x="1227600" y="2401200"/>
-            <a:ext cx="4233600" cy="558000"/>
+            <a:off x="1188000" y="2372400"/>
+            <a:ext cx="4312800" cy="540000"/>
           </a:xfrm>
           <a:prstGeom xmlns:a="http://schemas.openxmlformats.org/drawingml/2006/main" prst="rect">
             <a:avLst/>
@@ -1229,8 +1229,8 @@
         </p:nvSpPr>
         <p:spPr>
           <a:xfrm xmlns:a="http://schemas.openxmlformats.org/drawingml/2006/main">
-            <a:off x="1227600" y="3157200"/>
-            <a:ext cx="4233600" cy="1526400"/>
+            <a:off x="1188000" y="3132000"/>
+            <a:ext cx="4312800" cy="1479600"/>
           </a:xfrm>
           <a:prstGeom xmlns:a="http://schemas.openxmlformats.org/drawingml/2006/main" prst="rect">
             <a:avLst/>
@@ -1298,8 +1298,8 @@
         </p:nvSpPr>
         <p:spPr>
           <a:xfrm xmlns:a="http://schemas.openxmlformats.org/drawingml/2006/main">
-            <a:off x="6292800" y="1965600"/>
-            <a:ext cx="5104800" cy="3153600"/>
+            <a:off x="6292800" y="1976400"/>
+            <a:ext cx="5104800" cy="3034800"/>
           </a:xfrm>
           <a:prstGeom xmlns:a="http://schemas.openxmlformats.org/drawingml/2006/main" prst="roundRect">
             <a:avLst/>
@@ -1325,8 +1325,8 @@
         </p:nvSpPr>
         <p:spPr>
           <a:xfrm xmlns:a="http://schemas.openxmlformats.org/drawingml/2006/main">
-            <a:off x="6732000" y="2401200"/>
-            <a:ext cx="4233600" cy="558000"/>
+            <a:off x="6692400" y="2372400"/>
+            <a:ext cx="4312800" cy="540000"/>
           </a:xfrm>
           <a:prstGeom xmlns:a="http://schemas.openxmlformats.org/drawingml/2006/main" prst="rect">
             <a:avLst/>
@@ -1358,8 +1358,8 @@
         </p:nvSpPr>
         <p:spPr>
           <a:xfrm xmlns:a="http://schemas.openxmlformats.org/drawingml/2006/main">
-            <a:off x="6732000" y="3157200"/>
-            <a:ext cx="4233600" cy="1526400"/>
+            <a:off x="6692400" y="3132000"/>
+            <a:ext cx="4312800" cy="1479600"/>
           </a:xfrm>
           <a:prstGeom xmlns:a="http://schemas.openxmlformats.org/drawingml/2006/main" prst="rect">
             <a:avLst/>
@@ -1551,8 +1551,8 @@
         </p:nvSpPr>
         <p:spPr>
           <a:xfrm xmlns:a="http://schemas.openxmlformats.org/drawingml/2006/main">
-            <a:off x="792000" y="504000"/>
-            <a:ext cx="10609200" cy="648000"/>
+            <a:off x="792000" y="435600"/>
+            <a:ext cx="10609200" cy="558000"/>
           </a:xfrm>
           <a:prstGeom xmlns:a="http://schemas.openxmlformats.org/drawingml/2006/main" prst="rect">
             <a:avLst/>
@@ -1584,8 +1584,8 @@
         </p:nvSpPr>
         <p:spPr>
           <a:xfrm xmlns:a="http://schemas.openxmlformats.org/drawingml/2006/main">
-            <a:off x="792000" y="2592000"/>
-            <a:ext cx="1803600" cy="1656000"/>
+            <a:off x="792000" y="2332800"/>
+            <a:ext cx="1803600" cy="1800000"/>
           </a:xfrm>
           <a:prstGeom xmlns:a="http://schemas.openxmlformats.org/drawingml/2006/main" prst="roundRect">
             <a:avLst/>
@@ -1649,8 +1649,8 @@
         </p:nvSpPr>
         <p:spPr>
           <a:xfrm xmlns:a="http://schemas.openxmlformats.org/drawingml/2006/main">
-            <a:off x="2991600" y="2592000"/>
-            <a:ext cx="1803600" cy="1656000"/>
+            <a:off x="2991600" y="2332800"/>
+            <a:ext cx="1803600" cy="1800000"/>
           </a:xfrm>
           <a:prstGeom xmlns:a="http://schemas.openxmlformats.org/drawingml/2006/main" prst="roundRect">
             <a:avLst/>
@@ -1714,8 +1714,8 @@
         </p:nvSpPr>
         <p:spPr>
           <a:xfrm xmlns:a="http://schemas.openxmlformats.org/drawingml/2006/main">
-            <a:off x="5194800" y="2592000"/>
-            <a:ext cx="1803600" cy="1656000"/>
+            <a:off x="5194800" y="2332800"/>
+            <a:ext cx="1803600" cy="1800000"/>
           </a:xfrm>
           <a:prstGeom xmlns:a="http://schemas.openxmlformats.org/drawingml/2006/main" prst="roundRect">
             <a:avLst/>
@@ -1779,8 +1779,8 @@
         </p:nvSpPr>
         <p:spPr>
           <a:xfrm xmlns:a="http://schemas.openxmlformats.org/drawingml/2006/main">
-            <a:off x="7394400" y="2592000"/>
-            <a:ext cx="1803600" cy="1656000"/>
+            <a:off x="7394400" y="2332800"/>
+            <a:ext cx="1803600" cy="1800000"/>
           </a:xfrm>
           <a:prstGeom xmlns:a="http://schemas.openxmlformats.org/drawingml/2006/main" prst="roundRect">
             <a:avLst/>
@@ -1844,8 +1844,8 @@
         </p:nvSpPr>
         <p:spPr>
           <a:xfrm xmlns:a="http://schemas.openxmlformats.org/drawingml/2006/main">
-            <a:off x="9597600" y="2592000"/>
-            <a:ext cx="1803600" cy="1656000"/>
+            <a:off x="9597600" y="2332800"/>
+            <a:ext cx="1803600" cy="1800000"/>
           </a:xfrm>
           <a:prstGeom xmlns:a="http://schemas.openxmlformats.org/drawingml/2006/main" prst="roundRect">
             <a:avLst/>
@@ -1912,7 +1912,7 @@
         </p:nvCxnSpPr>
         <p:spPr>
           <a:xfrm xmlns:a="http://schemas.openxmlformats.org/drawingml/2006/main">
-            <a:off x="2595600" y="3420000"/>
+            <a:off x="2595600" y="3232800"/>
             <a:ext cx="396000" cy="0"/>
           </a:xfrm>
           <a:prstGeom xmlns:a="http://schemas.openxmlformats.org/drawingml/2006/main" prst="straightConnector1">
@@ -1937,7 +1937,7 @@
         </p:nvCxnSpPr>
         <p:spPr>
           <a:xfrm xmlns:a="http://schemas.openxmlformats.org/drawingml/2006/main">
-            <a:off x="4795200" y="3420000"/>
+            <a:off x="4795200" y="3232800"/>
             <a:ext cx="399600" cy="0"/>
           </a:xfrm>
           <a:prstGeom xmlns:a="http://schemas.openxmlformats.org/drawingml/2006/main" prst="straightConnector1">
@@ -1962,7 +1962,7 @@
         </p:nvCxnSpPr>
         <p:spPr>
           <a:xfrm xmlns:a="http://schemas.openxmlformats.org/drawingml/2006/main">
-            <a:off x="6998400" y="3420000"/>
+            <a:off x="6998400" y="3232800"/>
             <a:ext cx="396000" cy="0"/>
           </a:xfrm>
           <a:prstGeom xmlns:a="http://schemas.openxmlformats.org/drawingml/2006/main" prst="straightConnector1">
@@ -1987,7 +1987,7 @@
         </p:nvCxnSpPr>
         <p:spPr>
           <a:xfrm xmlns:a="http://schemas.openxmlformats.org/drawingml/2006/main">
-            <a:off x="9198000" y="3420000"/>
+            <a:off x="9198000" y="3232800"/>
             <a:ext cx="399600" cy="0"/>
           </a:xfrm>
           <a:prstGeom xmlns:a="http://schemas.openxmlformats.org/drawingml/2006/main" prst="straightConnector1">
@@ -2133,7 +2133,7 @@
         </p:nvSpPr>
         <p:spPr>
           <a:xfrm xmlns:a="http://schemas.openxmlformats.org/drawingml/2006/main">
-            <a:off x="792000" y="486000"/>
+            <a:off x="792000" y="435600"/>
             <a:ext cx="10609200" cy="662400"/>
           </a:xfrm>
           <a:prstGeom xmlns:a="http://schemas.openxmlformats.org/drawingml/2006/main" prst="rect">
@@ -2166,8 +2166,8 @@
         </p:nvSpPr>
         <p:spPr>
           <a:xfrm xmlns:a="http://schemas.openxmlformats.org/drawingml/2006/main">
-            <a:off x="792000" y="1490400"/>
-            <a:ext cx="3272400" cy="4935600"/>
+            <a:off x="792000" y="1414800"/>
+            <a:ext cx="3272400" cy="4651200"/>
           </a:xfrm>
           <a:prstGeom xmlns:a="http://schemas.openxmlformats.org/drawingml/2006/main" prst="roundRect">
             <a:avLst/>
@@ -2193,8 +2193,8 @@
         </p:nvSpPr>
         <p:spPr>
           <a:xfrm xmlns:a="http://schemas.openxmlformats.org/drawingml/2006/main">
-            <a:off x="1098000" y="1958400"/>
-            <a:ext cx="2660400" cy="684000"/>
+            <a:off x="1188000" y="1810800"/>
+            <a:ext cx="2480400" cy="666000"/>
           </a:xfrm>
           <a:prstGeom xmlns:a="http://schemas.openxmlformats.org/drawingml/2006/main" prst="rect">
             <a:avLst/>
@@ -2226,8 +2226,8 @@
         </p:nvSpPr>
         <p:spPr>
           <a:xfrm xmlns:a="http://schemas.openxmlformats.org/drawingml/2006/main">
-            <a:off x="1098000" y="2804400"/>
-            <a:ext cx="2660400" cy="1008000"/>
+            <a:off x="1188000" y="2696400"/>
+            <a:ext cx="2480400" cy="774000"/>
           </a:xfrm>
           <a:prstGeom xmlns:a="http://schemas.openxmlformats.org/drawingml/2006/main" prst="rect">
             <a:avLst/>
@@ -2259,8 +2259,8 @@
         </p:nvSpPr>
         <p:spPr>
           <a:xfrm xmlns:a="http://schemas.openxmlformats.org/drawingml/2006/main">
-            <a:off x="1098000" y="3974400"/>
-            <a:ext cx="2660400" cy="946800"/>
+            <a:off x="1188000" y="3693600"/>
+            <a:ext cx="2480400" cy="946800"/>
           </a:xfrm>
           <a:prstGeom xmlns:a="http://schemas.openxmlformats.org/drawingml/2006/main" prst="rect">
             <a:avLst/>
@@ -2272,7 +2272,7 @@
           <a:lstStyle xmlns:a="http://schemas.openxmlformats.org/drawingml/2006/main"/>
           <a:p xmlns:a="http://schemas.openxmlformats.org/drawingml/2006/main">
             <a:r>
-              <a:rPr lang="en-US" sz="1800">
+              <a:rPr lang="en-US" sz="1800" b="0">
                 <a:solidFill>
                   <a:srgbClr val="A0A6B0"/>
                 </a:solidFill>
@@ -2292,8 +2292,8 @@
         </p:nvSpPr>
         <p:spPr>
           <a:xfrm xmlns:a="http://schemas.openxmlformats.org/drawingml/2006/main">
-            <a:off x="4460400" y="1490400"/>
-            <a:ext cx="3272400" cy="4935600"/>
+            <a:off x="4460400" y="1414800"/>
+            <a:ext cx="3272400" cy="4651200"/>
           </a:xfrm>
           <a:prstGeom xmlns:a="http://schemas.openxmlformats.org/drawingml/2006/main" prst="roundRect">
             <a:avLst/>
@@ -2319,8 +2319,8 @@
         </p:nvSpPr>
         <p:spPr>
           <a:xfrm xmlns:a="http://schemas.openxmlformats.org/drawingml/2006/main">
-            <a:off x="4766400" y="1958400"/>
-            <a:ext cx="2660400" cy="684000"/>
+            <a:off x="4856400" y="1810800"/>
+            <a:ext cx="2480400" cy="666000"/>
           </a:xfrm>
           <a:prstGeom xmlns:a="http://schemas.openxmlformats.org/drawingml/2006/main" prst="rect">
             <a:avLst/>
@@ -2352,8 +2352,8 @@
         </p:nvSpPr>
         <p:spPr>
           <a:xfrm xmlns:a="http://schemas.openxmlformats.org/drawingml/2006/main">
-            <a:off x="4766400" y="2804400"/>
-            <a:ext cx="2660400" cy="1008000"/>
+            <a:off x="4856400" y="2696400"/>
+            <a:ext cx="2480400" cy="774000"/>
           </a:xfrm>
           <a:prstGeom xmlns:a="http://schemas.openxmlformats.org/drawingml/2006/main" prst="rect">
             <a:avLst/>
@@ -2385,8 +2385,8 @@
         </p:nvSpPr>
         <p:spPr>
           <a:xfrm xmlns:a="http://schemas.openxmlformats.org/drawingml/2006/main">
-            <a:off x="4766400" y="3974400"/>
-            <a:ext cx="2660400" cy="946800"/>
+            <a:off x="4856400" y="3693600"/>
+            <a:ext cx="2480400" cy="946800"/>
           </a:xfrm>
           <a:prstGeom xmlns:a="http://schemas.openxmlformats.org/drawingml/2006/main" prst="rect">
             <a:avLst/>
@@ -2398,7 +2398,7 @@
           <a:lstStyle xmlns:a="http://schemas.openxmlformats.org/drawingml/2006/main"/>
           <a:p xmlns:a="http://schemas.openxmlformats.org/drawingml/2006/main">
             <a:r>
-              <a:rPr lang="en-US" sz="1800">
+              <a:rPr lang="en-US" sz="1800" b="0">
                 <a:solidFill>
                   <a:srgbClr val="A0A6B0"/>
                 </a:solidFill>
@@ -2418,8 +2418,8 @@
         </p:nvSpPr>
         <p:spPr>
           <a:xfrm xmlns:a="http://schemas.openxmlformats.org/drawingml/2006/main">
-            <a:off x="8128800" y="1490400"/>
-            <a:ext cx="3272400" cy="4935600"/>
+            <a:off x="8128800" y="1414800"/>
+            <a:ext cx="3272400" cy="4651200"/>
           </a:xfrm>
           <a:prstGeom xmlns:a="http://schemas.openxmlformats.org/drawingml/2006/main" prst="roundRect">
             <a:avLst/>
@@ -2445,8 +2445,8 @@
         </p:nvSpPr>
         <p:spPr>
           <a:xfrm xmlns:a="http://schemas.openxmlformats.org/drawingml/2006/main">
-            <a:off x="8434800" y="1958400"/>
-            <a:ext cx="2660400" cy="684000"/>
+            <a:off x="8524800" y="1810800"/>
+            <a:ext cx="2480400" cy="666000"/>
           </a:xfrm>
           <a:prstGeom xmlns:a="http://schemas.openxmlformats.org/drawingml/2006/main" prst="rect">
             <a:avLst/>
@@ -2478,8 +2478,8 @@
         </p:nvSpPr>
         <p:spPr>
           <a:xfrm xmlns:a="http://schemas.openxmlformats.org/drawingml/2006/main">
-            <a:off x="8434800" y="2804400"/>
-            <a:ext cx="2660400" cy="1008000"/>
+            <a:off x="8524800" y="2696400"/>
+            <a:ext cx="2480400" cy="774000"/>
           </a:xfrm>
           <a:prstGeom xmlns:a="http://schemas.openxmlformats.org/drawingml/2006/main" prst="rect">
             <a:avLst/>
@@ -2511,8 +2511,8 @@
         </p:nvSpPr>
         <p:spPr>
           <a:xfrm xmlns:a="http://schemas.openxmlformats.org/drawingml/2006/main">
-            <a:off x="8434800" y="3974400"/>
-            <a:ext cx="2660400" cy="946800"/>
+            <a:off x="8524800" y="3693600"/>
+            <a:ext cx="2480400" cy="946800"/>
           </a:xfrm>
           <a:prstGeom xmlns:a="http://schemas.openxmlformats.org/drawingml/2006/main" prst="rect">
             <a:avLst/>
@@ -2524,7 +2524,7 @@
           <a:lstStyle xmlns:a="http://schemas.openxmlformats.org/drawingml/2006/main"/>
           <a:p xmlns:a="http://schemas.openxmlformats.org/drawingml/2006/main">
             <a:r>
-              <a:rPr lang="en-US" sz="1800">
+              <a:rPr lang="en-US" sz="1800" b="0">
                 <a:solidFill>
                   <a:srgbClr val="A0A6B0"/>
                 </a:solidFill>
@@ -2668,8 +2668,8 @@
         </p:nvSpPr>
         <p:spPr>
           <a:xfrm xmlns:a="http://schemas.openxmlformats.org/drawingml/2006/main">
-            <a:off x="792000" y="360000"/>
-            <a:ext cx="10609200" cy="648000"/>
+            <a:off x="792000" y="435600"/>
+            <a:ext cx="10609200" cy="558000"/>
           </a:xfrm>
           <a:prstGeom xmlns:a="http://schemas.openxmlformats.org/drawingml/2006/main" prst="rect">
             <a:avLst/>
@@ -3020,8 +3020,8 @@
         </p:nvSpPr>
         <p:spPr>
           <a:xfrm xmlns:a="http://schemas.openxmlformats.org/drawingml/2006/main">
-            <a:off x="792000" y="360000"/>
-            <a:ext cx="10609200" cy="648000"/>
+            <a:off x="792000" y="435600"/>
+            <a:ext cx="10609200" cy="558000"/>
           </a:xfrm>
           <a:prstGeom xmlns:a="http://schemas.openxmlformats.org/drawingml/2006/main" prst="rect">
             <a:avLst/>
@@ -3502,8 +3502,8 @@
         </p:nvSpPr>
         <p:spPr>
           <a:xfrm xmlns:a="http://schemas.openxmlformats.org/drawingml/2006/main">
-            <a:off x="792000" y="360000"/>
-            <a:ext cx="10609200" cy="648000"/>
+            <a:off x="792000" y="435600"/>
+            <a:ext cx="10609200" cy="558000"/>
           </a:xfrm>
           <a:prstGeom xmlns:a="http://schemas.openxmlformats.org/drawingml/2006/main" prst="rect">
             <a:avLst/>
@@ -3849,8 +3849,8 @@
         </p:nvSpPr>
         <p:spPr>
           <a:xfrm xmlns:a="http://schemas.openxmlformats.org/drawingml/2006/main">
-            <a:off x="792000" y="1872000"/>
-            <a:ext cx="10609200" cy="1008000"/>
+            <a:off x="792000" y="1796400"/>
+            <a:ext cx="10609200" cy="936000"/>
           </a:xfrm>
           <a:prstGeom xmlns:a="http://schemas.openxmlformats.org/drawingml/2006/main" prst="rect">
             <a:avLst/>
@@ -3883,8 +3883,8 @@
         </p:nvSpPr>
         <p:spPr>
           <a:xfrm xmlns:a="http://schemas.openxmlformats.org/drawingml/2006/main">
-            <a:off x="1512000" y="3024000"/>
-            <a:ext cx="9169200" cy="720000"/>
+            <a:off x="1188000" y="2952000"/>
+            <a:ext cx="9817200" cy="720000"/>
           </a:xfrm>
           <a:prstGeom xmlns:a="http://schemas.openxmlformats.org/drawingml/2006/main" prst="rect">
             <a:avLst/>
@@ -3917,8 +3917,8 @@
         </p:nvSpPr>
         <p:spPr>
           <a:xfrm xmlns:a="http://schemas.openxmlformats.org/drawingml/2006/main">
-            <a:off x="4294800" y="4248000"/>
-            <a:ext cx="3600000" cy="648000"/>
+            <a:off x="4294800" y="4068000"/>
+            <a:ext cx="3600000" cy="612000"/>
           </a:xfrm>
           <a:prstGeom xmlns:a="http://schemas.openxmlformats.org/drawingml/2006/main" prst="roundRect">
             <a:avLst/>

</xml_diff>

<commit_message>
feat(ui-kit): raise all recipes onto StageMetrics + best demo
Enforce the React-like spacing contract across the recipe surface:

- layout.solve strips vertical Text weights (no hollow body frames)
- _base_props always loads StageMetrics margin/gap/pad
- mission_vision, puzzle, pillars, stairs, checklist use content bands
- comparison_panels wrap-aware body height; tile-row helper for equal chips

Ship demo/designmd-pptx-best-v2.1.2.pptx (10-slide narrative, issues 0,
a11y clean) and keep intro filename as the same build.
</commit_message>
<xml_diff>
--- a/demo/designmd-pptx-intro-v2.1.2.pptx
+++ b/demo/designmd-pptx-intro-v2.1.2.pptx
@@ -5,15 +5,16 @@
     <p:sldMasterId xmlns:r="http://schemas.openxmlformats.org/officeDocument/2006/relationships" id="2147483648" r:id="rId1"/>
   </p:sldMasterIdLst>
   <p:sldIdLst>
-    <p:sldId id="256" r:id="R614123432d444c07"/>
-    <p:sldId id="257" r:id="Rf8453ea318854e16"/>
-    <p:sldId id="258" r:id="R65faa2c9d32d41a7"/>
-    <p:sldId id="259" r:id="Rd41056334a704d99"/>
-    <p:sldId id="260" r:id="Rdfe49b9966374693"/>
-    <p:sldId id="261" r:id="Rc24419b3ada642b9"/>
-    <p:sldId id="262" r:id="Rbd524f50dafd4511"/>
-    <p:sldId id="263" r:id="R1e8254baba78415c"/>
-    <p:sldId id="264" r:id="R4f9601df485a4b5a"/>
+    <p:sldId id="256" r:id="R269e527a49884e5c"/>
+    <p:sldId id="257" r:id="R2b22566404564b19"/>
+    <p:sldId id="258" r:id="R962bf375e0a946b7"/>
+    <p:sldId id="259" r:id="R025b11492b314df4"/>
+    <p:sldId id="260" r:id="R7758b82bf54f4e1b"/>
+    <p:sldId id="261" r:id="R8dc64986fcda428b"/>
+    <p:sldId id="262" r:id="Rb64beeff4547457a"/>
+    <p:sldId id="263" r:id="R5ac571f2bc624a7b"/>
+    <p:sldId id="264" r:id="R0a81eeb369bc4425"/>
+    <p:sldId id="265" r:id="Rc53d8e01c0cd422d"/>
   </p:sldIdLst>
   <p:sldSz cx="12192000" cy="6858000"/>
   <p:notesSz cx="6858000" cy="9144000"/>
@@ -62,7 +63,7 @@
           <a:p xmlns:a="http://schemas.openxmlformats.org/drawingml/2006/main">
             <a:r>
               <a:rPr lang="en-US"/>
-              <a:t>The contract is the brand file — not the agent improvising layout.</a:t>
+              <a:t>Everything else is a derivative of this file.</a:t>
             </a:r>
           </a:p>
         </p:txBody>
@@ -166,7 +167,7 @@
           <a:p xmlns:a="http://schemas.openxmlformats.org/drawingml/2006/main">
             <a:r>
               <a:rPr lang="en-US"/>
-              <a:t>Five steps, one owner each. Gate 3 is not optional for ship.</a:t>
+              <a:t>Five steps. One owner each. Gate 3 is not optional.</a:t>
             </a:r>
           </a:p>
         </p:txBody>
@@ -270,7 +271,7 @@
           <a:p xmlns:a="http://schemas.openxmlformats.org/drawingml/2006/main">
             <a:r>
               <a:rPr lang="en-US"/>
-              <a:t>You cannot skip a stair — name the exit criteria per step.</a:t>
+              <a:t>Mission is timeless; vision is dated and measurable.</a:t>
             </a:r>
           </a:p>
         </p:txBody>
@@ -281,6 +282,58 @@
 </file>
 
 <file path=ppt/notesSlides/notesSlide6.xml><?xml version="1.0" encoding="utf-8"?>
+<p:notes xmlns:p="http://schemas.openxmlformats.org/presentationml/2006/main">
+  <p:cSld>
+    <p:spTree>
+      <p:nvGrpSpPr>
+        <p:cNvPr id="1" name=""/>
+        <p:cNvGrpSpPr/>
+        <p:nvPr/>
+      </p:nvGrpSpPr>
+      <p:grpSpPr>
+        <a:xfrm xmlns:a="http://schemas.openxmlformats.org/drawingml/2006/main"/>
+      </p:grpSpPr>
+      <p:sp>
+        <p:nvSpPr>
+          <p:cNvPr id="2" name="Slide Image Placeholder 1"/>
+          <p:cNvSpPr/>
+          <p:nvPr>
+            <p:ph type="sldImg" idx="0"/>
+          </p:nvPr>
+        </p:nvSpPr>
+        <p:spPr/>
+        <p:txBody>
+          <a:bodyPr xmlns:a="http://schemas.openxmlformats.org/drawingml/2006/main"/>
+          <a:lstStyle xmlns:a="http://schemas.openxmlformats.org/drawingml/2006/main"/>
+          <a:p xmlns:a="http://schemas.openxmlformats.org/drawingml/2006/main"/>
+        </p:txBody>
+      </p:sp>
+      <p:sp>
+        <p:nvSpPr>
+          <p:cNvPr id="3" name="Notes Placeholder 2"/>
+          <p:cNvSpPr/>
+          <p:nvPr>
+            <p:ph type="body" idx="1"/>
+          </p:nvPr>
+        </p:nvSpPr>
+        <p:spPr/>
+        <p:txBody>
+          <a:bodyPr xmlns:a="http://schemas.openxmlformats.org/drawingml/2006/main"/>
+          <a:lstStyle xmlns:a="http://schemas.openxmlformats.org/drawingml/2006/main"/>
+          <a:p xmlns:a="http://schemas.openxmlformats.org/drawingml/2006/main">
+            <a:r>
+              <a:rPr lang="en-US"/>
+              <a:t>You cannot skip a stair — name the exit criteria per step.</a:t>
+            </a:r>
+          </a:p>
+        </p:txBody>
+      </p:sp>
+    </p:spTree>
+  </p:cSld>
+</p:notes>
+</file>
+
+<file path=ppt/notesSlides/notesSlide7.xml><?xml version="1.0" encoding="utf-8"?>
 <p:notes xmlns:p="http://schemas.openxmlformats.org/presentationml/2006/main">
   <p:cSld>
     <p:spTree>
@@ -756,7 +809,7 @@
                 <a:latin typeface="Arial"/>
                 <a:ea typeface="Arial"/>
               </a:rPr>
-              <a:t>Brand design that becomes a real PowerPoint deck</a:t>
+              <a:t>Brand design that becomes a real deck</a:t>
             </a:r>
           </a:p>
         </p:txBody>
@@ -790,7 +843,7 @@
                 <a:latin typeface="Arial"/>
                 <a:ea typeface="Arial"/>
               </a:rPr>
-              <a:t>v2.1.2  ·  Flagship intro  ·  English</a:t>
+              <a:t>v2.1.2  ·  English  ·  Precision pipeline</a:t>
             </a:r>
           </a:p>
         </p:txBody>
@@ -885,6 +938,237 @@
 </p:sld>
 </file>
 
+<file path=ppt/slides/slide10.xml><?xml version="1.0" encoding="utf-8"?>
+<p:sld xmlns:p="http://schemas.openxmlformats.org/presentationml/2006/main">
+  <p:cSld>
+    <p:bg>
+      <p:bgPr>
+        <a:solidFill xmlns:a="http://schemas.openxmlformats.org/drawingml/2006/main">
+          <a:srgbClr val="000000"/>
+        </a:solidFill>
+      </p:bgPr>
+    </p:bg>
+    <p:spTree>
+      <p:nvGrpSpPr>
+        <p:cNvPr id="1" name=""/>
+        <p:cNvGrpSpPr/>
+        <p:nvPr/>
+      </p:nvGrpSpPr>
+      <p:grpSpPr/>
+      <p:sp>
+        <p:nvSpPr>
+          <p:cNvPr id="100061" name="CloseTitle"/>
+          <p:cNvSpPr txBox="1"/>
+          <p:nvPr/>
+        </p:nvSpPr>
+        <p:spPr>
+          <a:xfrm xmlns:a="http://schemas.openxmlformats.org/drawingml/2006/main">
+            <a:off x="792000" y="1796400"/>
+            <a:ext cx="10609200" cy="936000"/>
+          </a:xfrm>
+          <a:prstGeom xmlns:a="http://schemas.openxmlformats.org/drawingml/2006/main" prst="rect">
+            <a:avLst/>
+          </a:prstGeom>
+          <a:noFill xmlns:a="http://schemas.openxmlformats.org/drawingml/2006/main"/>
+        </p:spPr>
+        <p:txBody>
+          <a:bodyPr xmlns:a="http://schemas.openxmlformats.org/drawingml/2006/main"/>
+          <a:lstStyle xmlns:a="http://schemas.openxmlformats.org/drawingml/2006/main"/>
+          <a:p xmlns:a="http://schemas.openxmlformats.org/drawingml/2006/main">
+            <a:pPr algn="ctr"/>
+            <a:r>
+              <a:rPr lang="en-US" sz="4400" b="1">
+                <a:solidFill>
+                  <a:srgbClr val="F5F5F7"/>
+                </a:solidFill>
+                <a:latin typeface="Arial"/>
+                <a:ea typeface="Arial"/>
+              </a:rPr>
+              <a:t>Start with the brand file</a:t>
+            </a:r>
+          </a:p>
+        </p:txBody>
+      </p:sp>
+      <p:sp>
+        <p:nvSpPr>
+          <p:cNvPr id="100062" name="CloseBody"/>
+          <p:cNvSpPr txBox="1"/>
+          <p:nvPr/>
+        </p:nvSpPr>
+        <p:spPr>
+          <a:xfrm xmlns:a="http://schemas.openxmlformats.org/drawingml/2006/main">
+            <a:off x="1188000" y="2952000"/>
+            <a:ext cx="9817200" cy="720000"/>
+          </a:xfrm>
+          <a:prstGeom xmlns:a="http://schemas.openxmlformats.org/drawingml/2006/main" prst="rect">
+            <a:avLst/>
+          </a:prstGeom>
+          <a:noFill xmlns:a="http://schemas.openxmlformats.org/drawingml/2006/main"/>
+        </p:spPr>
+        <p:txBody>
+          <a:bodyPr xmlns:a="http://schemas.openxmlformats.org/drawingml/2006/main"/>
+          <a:lstStyle xmlns:a="http://schemas.openxmlformats.org/drawingml/2006/main"/>
+          <a:p xmlns:a="http://schemas.openxmlformats.org/drawingml/2006/main">
+            <a:pPr algn="ctr"/>
+            <a:r>
+              <a:rPr lang="en-US" sz="1800">
+                <a:solidFill>
+                  <a:srgbClr val="A0A6B0"/>
+                </a:solidFill>
+                <a:latin typeface="Arial"/>
+                <a:ea typeface="Arial"/>
+              </a:rPr>
+              <a:t>doctor --ensure · compose · scaffold · apply --screenshot</a:t>
+            </a:r>
+          </a:p>
+        </p:txBody>
+      </p:sp>
+      <p:sp>
+        <p:nvSpPr>
+          <p:cNvPr id="100063" name="CloseCta"/>
+          <p:cNvSpPr/>
+          <p:nvPr/>
+        </p:nvSpPr>
+        <p:spPr>
+          <a:xfrm xmlns:a="http://schemas.openxmlformats.org/drawingml/2006/main">
+            <a:off x="4294800" y="4068000"/>
+            <a:ext cx="3600000" cy="612000"/>
+          </a:xfrm>
+          <a:prstGeom xmlns:a="http://schemas.openxmlformats.org/drawingml/2006/main" prst="roundRect">
+            <a:avLst/>
+          </a:prstGeom>
+          <a:solidFill xmlns:a="http://schemas.openxmlformats.org/drawingml/2006/main">
+            <a:srgbClr val="0B5FFF"/>
+          </a:solidFill>
+          <a:ln xmlns:a="http://schemas.openxmlformats.org/drawingml/2006/main">
+            <a:noFill/>
+          </a:ln>
+        </p:spPr>
+        <p:txBody>
+          <a:bodyPr xmlns:a="http://schemas.openxmlformats.org/drawingml/2006/main" anchor="ctr"/>
+          <a:lstStyle xmlns:a="http://schemas.openxmlformats.org/drawingml/2006/main"/>
+          <a:p xmlns:a="http://schemas.openxmlformats.org/drawingml/2006/main">
+            <a:pPr algn="ctr"/>
+            <a:r>
+              <a:rPr lang="en-US" sz="1800" b="1">
+                <a:solidFill>
+                  <a:srgbClr val="FFFFFF"/>
+                </a:solidFill>
+                <a:latin typeface="Arial"/>
+                <a:ea typeface="Arial"/>
+              </a:rPr>
+              <a:t>doctor --ensure</a:t>
+            </a:r>
+          </a:p>
+        </p:txBody>
+      </p:sp>
+    </p:spTree>
+  </p:cSld>
+  <p:transition spd="med">
+    <p:fade/>
+  </p:transition>
+  <p:timing>
+    <p:tnLst>
+      <p:par>
+        <p:cTn id="1" dur="indefinite" restart="never" nodeType="tmRoot">
+          <p:childTnLst>
+            <p:seq concurrent="1" nextAc="seek">
+              <p:cTn id="2" dur="indefinite" nodeType="mainSeq">
+                <p:childTnLst>
+                  <p:par>
+                    <p:cTn id="3" fill="hold">
+                      <p:stCondLst>
+                        <p:cond delay="indefinite"/>
+                      </p:stCondLst>
+                      <p:childTnLst>
+                        <p:par>
+                          <p:cTn id="4" fill="hold">
+                            <p:stCondLst>
+                              <p:cond delay="0"/>
+                            </p:stCondLst>
+                            <p:childTnLst>
+                              <p:par>
+                                <p:cTn id="5" presetID="10" presetClass="entr" presetSubtype="0" fill="hold" grpId="0" nodeType="clickEffect">
+                                  <p:stCondLst>
+                                    <p:cond delay="0"/>
+                                  </p:stCondLst>
+                                  <p:childTnLst>
+                                    <p:animEffect transition="in" filter="fade">
+                                      <p:cBhvr>
+                                        <p:cTn id="6" dur="500"/>
+                                        <p:tgtEl>
+                                          <p:spTgt spid="100061"/>
+                                        </p:tgtEl>
+                                      </p:cBhvr>
+                                    </p:animEffect>
+                                  </p:childTnLst>
+                                </p:cTn>
+                              </p:par>
+                              <p:par>
+                                <p:cTn id="7" presetID="10" presetClass="entr" presetSubtype="0" fill="hold" grpId="0" nodeType="afterEffect">
+                                  <p:stCondLst>
+                                    <p:cond delay="150"/>
+                                  </p:stCondLst>
+                                  <p:childTnLst>
+                                    <p:animEffect transition="in" filter="fade">
+                                      <p:cBhvr>
+                                        <p:cTn id="8" dur="500"/>
+                                        <p:tgtEl>
+                                          <p:spTgt spid="100062"/>
+                                        </p:tgtEl>
+                                      </p:cBhvr>
+                                    </p:animEffect>
+                                  </p:childTnLst>
+                                </p:cTn>
+                              </p:par>
+                              <p:par>
+                                <p:cTn id="9" presetID="10" presetClass="entr" presetSubtype="0" fill="hold" grpId="0" nodeType="afterEffect">
+                                  <p:stCondLst>
+                                    <p:cond delay="300"/>
+                                  </p:stCondLst>
+                                  <p:childTnLst>
+                                    <p:animEffect transition="in" filter="fade">
+                                      <p:cBhvr>
+                                        <p:cTn id="10" dur="500"/>
+                                        <p:tgtEl>
+                                          <p:spTgt spid="100063"/>
+                                        </p:tgtEl>
+                                      </p:cBhvr>
+                                    </p:animEffect>
+                                  </p:childTnLst>
+                                </p:cTn>
+                              </p:par>
+                            </p:childTnLst>
+                          </p:cTn>
+                        </p:par>
+                      </p:childTnLst>
+                    </p:cTn>
+                  </p:par>
+                </p:childTnLst>
+              </p:cTn>
+              <p:prevCondLst>
+                <p:cond evt="onPrev" delay="0">
+                  <p:tgtEl>
+                    <p:sldTgt/>
+                  </p:tgtEl>
+                </p:cond>
+              </p:prevCondLst>
+              <p:nextCondLst>
+                <p:cond evt="onNext" delay="0">
+                  <p:tgtEl>
+                    <p:sldTgt/>
+                  </p:tgtEl>
+                </p:cond>
+              </p:nextCondLst>
+            </p:seq>
+          </p:childTnLst>
+        </p:cTn>
+      </p:par>
+    </p:tnLst>
+  </p:timing>
+</p:sld>
+</file>
+
 <file path=ppt/slides/slide2.xml><?xml version="1.0" encoding="utf-8"?>
 <p:sld xmlns:p="http://schemas.openxmlformats.org/presentationml/2006/main">
   <p:cSld>
@@ -965,7 +1249,7 @@
                 <a:latin typeface="Arial"/>
                 <a:ea typeface="Arial"/>
               </a:rPr>
-              <a:t>One brand source of truth</a:t>
+              <a:t>The brand is the contract</a:t>
             </a:r>
           </a:p>
         </p:txBody>
@@ -999,7 +1283,7 @@
                 <a:latin typeface="Arial"/>
                 <a:ea typeface="Arial"/>
               </a:rPr>
-              <a:t>Tokens, recipes, and staging-safe apply — not a blank slide and a prayer.</a:t>
+              <a:t>Tokens, recipes, staging-safe apply — not a blank slide and a prayer.</a:t>
             </a:r>
           </a:p>
         </p:txBody>
@@ -1169,8 +1453,8 @@
         </p:nvSpPr>
         <p:spPr>
           <a:xfrm xmlns:a="http://schemas.openxmlformats.org/drawingml/2006/main">
-            <a:off x="792000" y="1976400"/>
-            <a:ext cx="5104800" cy="3034800"/>
+            <a:off x="792000" y="1980000"/>
+            <a:ext cx="5104800" cy="3020400"/>
           </a:xfrm>
           <a:prstGeom xmlns:a="http://schemas.openxmlformats.org/drawingml/2006/main" prst="roundRect">
             <a:avLst/>
@@ -1196,7 +1480,7 @@
         </p:nvSpPr>
         <p:spPr>
           <a:xfrm xmlns:a="http://schemas.openxmlformats.org/drawingml/2006/main">
-            <a:off x="1188000" y="2372400"/>
+            <a:off x="1188000" y="2376000"/>
             <a:ext cx="4312800" cy="540000"/>
           </a:xfrm>
           <a:prstGeom xmlns:a="http://schemas.openxmlformats.org/drawingml/2006/main" prst="rect">
@@ -1229,8 +1513,8 @@
         </p:nvSpPr>
         <p:spPr>
           <a:xfrm xmlns:a="http://schemas.openxmlformats.org/drawingml/2006/main">
-            <a:off x="1188000" y="3132000"/>
-            <a:ext cx="4312800" cy="1479600"/>
+            <a:off x="1188000" y="3135600"/>
+            <a:ext cx="4312800" cy="1468800"/>
           </a:xfrm>
           <a:prstGeom xmlns:a="http://schemas.openxmlformats.org/drawingml/2006/main" prst="rect">
             <a:avLst/>
@@ -1298,8 +1582,8 @@
         </p:nvSpPr>
         <p:spPr>
           <a:xfrm xmlns:a="http://schemas.openxmlformats.org/drawingml/2006/main">
-            <a:off x="6292800" y="1976400"/>
-            <a:ext cx="5104800" cy="3034800"/>
+            <a:off x="6292800" y="1980000"/>
+            <a:ext cx="5104800" cy="3020400"/>
           </a:xfrm>
           <a:prstGeom xmlns:a="http://schemas.openxmlformats.org/drawingml/2006/main" prst="roundRect">
             <a:avLst/>
@@ -1325,7 +1609,7 @@
         </p:nvSpPr>
         <p:spPr>
           <a:xfrm xmlns:a="http://schemas.openxmlformats.org/drawingml/2006/main">
-            <a:off x="6692400" y="2372400"/>
+            <a:off x="6692400" y="2376000"/>
             <a:ext cx="4312800" cy="540000"/>
           </a:xfrm>
           <a:prstGeom xmlns:a="http://schemas.openxmlformats.org/drawingml/2006/main" prst="rect">
@@ -1358,8 +1642,8 @@
         </p:nvSpPr>
         <p:spPr>
           <a:xfrm xmlns:a="http://schemas.openxmlformats.org/drawingml/2006/main">
-            <a:off x="6692400" y="3132000"/>
-            <a:ext cx="4312800" cy="1479600"/>
+            <a:off x="6692400" y="3135600"/>
+            <a:ext cx="4312800" cy="1468800"/>
           </a:xfrm>
           <a:prstGeom xmlns:a="http://schemas.openxmlformats.org/drawingml/2006/main" prst="rect">
             <a:avLst/>
@@ -1571,7 +1855,7 @@
                 <a:latin typeface="Arial"/>
                 <a:ea typeface="Arial"/>
               </a:rPr>
-              <a:t>Authoring pipeline</a:t>
+              <a:t>One pipeline</a:t>
             </a:r>
           </a:p>
         </p:txBody>
@@ -2701,8 +2985,8 @@
         </p:nvSpPr>
         <p:spPr>
           <a:xfrm xmlns:a="http://schemas.openxmlformats.org/drawingml/2006/main">
-            <a:off x="792000" y="1800000"/>
-            <a:ext cx="3416400" cy="4140000"/>
+            <a:off x="792000" y="2545200"/>
+            <a:ext cx="3272400" cy="2678400"/>
           </a:xfrm>
           <a:prstGeom xmlns:a="http://schemas.openxmlformats.org/drawingml/2006/main" prst="roundRect">
             <a:avLst/>
@@ -2753,7 +3037,7 @@
                 <a:latin typeface="Arial"/>
                 <a:ea typeface="Arial"/>
               </a:rPr>
-              <a:t>Shape-level batch for DESIGN.md-exact decks</a:t>
+              <a:t>Shape-level precision for DESIGN.md decks</a:t>
             </a:r>
           </a:p>
         </p:txBody>
@@ -2766,8 +3050,8 @@
         </p:nvSpPr>
         <p:spPr>
           <a:xfrm xmlns:a="http://schemas.openxmlformats.org/drawingml/2006/main">
-            <a:off x="4388400" y="1944000"/>
-            <a:ext cx="3416400" cy="3996000"/>
+            <a:off x="4460400" y="2026800"/>
+            <a:ext cx="3272400" cy="3200400"/>
           </a:xfrm>
           <a:prstGeom xmlns:a="http://schemas.openxmlformats.org/drawingml/2006/main" prst="roundRect">
             <a:avLst/>
@@ -2831,8 +3115,8 @@
         </p:nvSpPr>
         <p:spPr>
           <a:xfrm xmlns:a="http://schemas.openxmlformats.org/drawingml/2006/main">
-            <a:off x="7984800" y="2088000"/>
-            <a:ext cx="3416400" cy="3852000"/>
+            <a:off x="8128800" y="1504800"/>
+            <a:ext cx="3272400" cy="3722400"/>
           </a:xfrm>
           <a:prstGeom xmlns:a="http://schemas.openxmlformats.org/drawingml/2006/main" prst="roundRect">
             <a:avLst/>
@@ -3014,7 +3298,7 @@
       <p:grpSpPr/>
       <p:sp>
         <p:nvSpPr>
-          <p:cNvPr id="100042" name="StairsTitle"/>
+          <p:cNvPr id="100042" name="MVTitle"/>
           <p:cNvSpPr txBox="1"/>
           <p:nvPr/>
         </p:nvSpPr>
@@ -3040,21 +3324,21 @@
                 <a:latin typeface="Arial"/>
                 <a:ea typeface="Arial"/>
               </a:rPr>
-              <a:t>Quality is a staircase</a:t>
-            </a:r>
-          </a:p>
-        </p:txBody>
-      </p:sp>
-      <p:sp>
-        <p:nvSpPr>
-          <p:cNvPr id="100043" name="Stair1"/>
+              <a:t>North star</a:t>
+            </a:r>
+          </a:p>
+        </p:txBody>
+      </p:sp>
+      <p:sp>
+        <p:nvSpPr>
+          <p:cNvPr id="100043" name="MVPanel1"/>
           <p:cNvSpPr/>
           <p:nvPr/>
         </p:nvSpPr>
         <p:spPr>
           <a:xfrm xmlns:a="http://schemas.openxmlformats.org/drawingml/2006/main">
-            <a:off x="835200" y="4680000"/>
-            <a:ext cx="2034000" cy="1368000"/>
+            <a:off x="792000" y="2196000"/>
+            <a:ext cx="5104800" cy="2448000"/>
           </a:xfrm>
           <a:prstGeom xmlns:a="http://schemas.openxmlformats.org/drawingml/2006/main" prst="roundRect">
             <a:avLst/>
@@ -3067,254 +3351,87 @@
           </a:ln>
         </p:spPr>
         <p:txBody>
-          <a:bodyPr xmlns:a="http://schemas.openxmlformats.org/drawingml/2006/main" anchor="ctr"/>
-          <a:lstStyle xmlns:a="http://schemas.openxmlformats.org/drawingml/2006/main"/>
-          <a:p xmlns:a="http://schemas.openxmlformats.org/drawingml/2006/main">
-            <a:pPr algn="ctr"/>
-            <a:r>
-              <a:rPr lang="en-US" sz="1800" b="1">
-                <a:solidFill>
-                  <a:srgbClr val="F5F5F7"/>
-                </a:solidFill>
-                <a:latin typeface="Arial"/>
-                <a:ea typeface="Arial"/>
-              </a:rPr>
-              <a:t>1</a:t>
-            </a:r>
-          </a:p>
-          <a:p xmlns:a="http://schemas.openxmlformats.org/drawingml/2006/main">
-            <a:pPr algn="ctr"/>
-            <a:r>
-              <a:rPr lang="en-US" sz="1800" b="1">
-                <a:solidFill>
-                  <a:srgbClr val="F5F5F7"/>
-                </a:solidFill>
-                <a:latin typeface="Arial"/>
-                <a:ea typeface="Arial"/>
-              </a:rPr>
-              <a:t>Tokens</a:t>
-            </a:r>
-          </a:p>
-          <a:p xmlns:a="http://schemas.openxmlformats.org/drawingml/2006/main">
-            <a:pPr algn="ctr"/>
-            <a:r>
-              <a:rPr lang="en-US" sz="1800" b="1">
-                <a:solidFill>
-                  <a:srgbClr val="F5F5F7"/>
-                </a:solidFill>
-                <a:latin typeface="Arial"/>
-                <a:ea typeface="Arial"/>
-              </a:rPr>
-              <a:t>Brand floors</a:t>
-            </a:r>
-          </a:p>
-        </p:txBody>
-      </p:sp>
-      <p:sp>
-        <p:nvSpPr>
-          <p:cNvPr id="100044" name="Stair2"/>
+          <a:bodyPr xmlns:a="http://schemas.openxmlformats.org/drawingml/2006/main"/>
+          <a:lstStyle xmlns:a="http://schemas.openxmlformats.org/drawingml/2006/main"/>
+          <a:p xmlns:a="http://schemas.openxmlformats.org/drawingml/2006/main"/>
+        </p:txBody>
+      </p:sp>
+      <p:sp>
+        <p:nvSpPr>
+          <p:cNvPr id="100044" name="MVLab1"/>
+          <p:cNvSpPr txBox="1"/>
+          <p:nvPr/>
+        </p:nvSpPr>
+        <p:spPr>
+          <a:xfrm xmlns:a="http://schemas.openxmlformats.org/drawingml/2006/main">
+            <a:off x="1188000" y="2592000"/>
+            <a:ext cx="4312800" cy="540000"/>
+          </a:xfrm>
+          <a:prstGeom xmlns:a="http://schemas.openxmlformats.org/drawingml/2006/main" prst="rect">
+            <a:avLst/>
+          </a:prstGeom>
+          <a:noFill xmlns:a="http://schemas.openxmlformats.org/drawingml/2006/main"/>
+        </p:spPr>
+        <p:txBody>
+          <a:bodyPr xmlns:a="http://schemas.openxmlformats.org/drawingml/2006/main"/>
+          <a:lstStyle xmlns:a="http://schemas.openxmlformats.org/drawingml/2006/main"/>
+          <a:p xmlns:a="http://schemas.openxmlformats.org/drawingml/2006/main">
+            <a:r>
+              <a:rPr lang="en-US" sz="2800" b="1">
+                <a:solidFill>
+                  <a:srgbClr val="F5F5F7"/>
+                </a:solidFill>
+                <a:latin typeface="Arial"/>
+                <a:ea typeface="Arial"/>
+              </a:rPr>
+              <a:t>Mission</a:t>
+            </a:r>
+          </a:p>
+        </p:txBody>
+      </p:sp>
+      <p:sp>
+        <p:nvSpPr>
+          <p:cNvPr id="100045" name="MVBody1"/>
+          <p:cNvSpPr txBox="1"/>
+          <p:nvPr/>
+        </p:nvSpPr>
+        <p:spPr>
+          <a:xfrm xmlns:a="http://schemas.openxmlformats.org/drawingml/2006/main">
+            <a:off x="1188000" y="3355200"/>
+            <a:ext cx="4312800" cy="896400"/>
+          </a:xfrm>
+          <a:prstGeom xmlns:a="http://schemas.openxmlformats.org/drawingml/2006/main" prst="rect">
+            <a:avLst/>
+          </a:prstGeom>
+          <a:noFill xmlns:a="http://schemas.openxmlformats.org/drawingml/2006/main"/>
+        </p:spPr>
+        <p:txBody>
+          <a:bodyPr xmlns:a="http://schemas.openxmlformats.org/drawingml/2006/main"/>
+          <a:lstStyle xmlns:a="http://schemas.openxmlformats.org/drawingml/2006/main"/>
+          <a:p xmlns:a="http://schemas.openxmlformats.org/drawingml/2006/main">
+            <a:r>
+              <a:rPr lang="en-US" sz="1800">
+                <a:solidFill>
+                  <a:srgbClr val="A0A6B0"/>
+                </a:solidFill>
+                <a:latin typeface="Arial"/>
+                <a:ea typeface="Arial"/>
+              </a:rPr>
+              <a:t>Make every brand deck as sharp as the product it sells.</a:t>
+            </a:r>
+          </a:p>
+        </p:txBody>
+      </p:sp>
+      <p:sp>
+        <p:nvSpPr>
+          <p:cNvPr id="100046" name="MVPanel2"/>
           <p:cNvSpPr/>
           <p:nvPr/>
         </p:nvSpPr>
         <p:spPr>
           <a:xfrm xmlns:a="http://schemas.openxmlformats.org/drawingml/2006/main">
-            <a:off x="2955600" y="3852000"/>
-            <a:ext cx="2034000" cy="2196000"/>
-          </a:xfrm>
-          <a:prstGeom xmlns:a="http://schemas.openxmlformats.org/drawingml/2006/main" prst="roundRect">
-            <a:avLst/>
-          </a:prstGeom>
-          <a:solidFill xmlns:a="http://schemas.openxmlformats.org/drawingml/2006/main">
-            <a:srgbClr val="1C1C1E"/>
-          </a:solidFill>
-          <a:ln xmlns:a="http://schemas.openxmlformats.org/drawingml/2006/main">
-            <a:noFill/>
-          </a:ln>
-        </p:spPr>
-        <p:txBody>
-          <a:bodyPr xmlns:a="http://schemas.openxmlformats.org/drawingml/2006/main" anchor="ctr"/>
-          <a:lstStyle xmlns:a="http://schemas.openxmlformats.org/drawingml/2006/main"/>
-          <a:p xmlns:a="http://schemas.openxmlformats.org/drawingml/2006/main">
-            <a:pPr algn="ctr"/>
-            <a:r>
-              <a:rPr lang="en-US" sz="1800" b="1">
-                <a:solidFill>
-                  <a:srgbClr val="F5F5F7"/>
-                </a:solidFill>
-                <a:latin typeface="Arial"/>
-                <a:ea typeface="Arial"/>
-              </a:rPr>
-              <a:t>2</a:t>
-            </a:r>
-          </a:p>
-          <a:p xmlns:a="http://schemas.openxmlformats.org/drawingml/2006/main">
-            <a:pPr algn="ctr"/>
-            <a:r>
-              <a:rPr lang="en-US" sz="1800" b="1">
-                <a:solidFill>
-                  <a:srgbClr val="F5F5F7"/>
-                </a:solidFill>
-                <a:latin typeface="Arial"/>
-                <a:ea typeface="Arial"/>
-              </a:rPr>
-              <a:t>Fit</a:t>
-            </a:r>
-          </a:p>
-          <a:p xmlns:a="http://schemas.openxmlformats.org/drawingml/2006/main">
-            <a:pPr algn="ctr"/>
-            <a:r>
-              <a:rPr lang="en-US" sz="1800" b="1">
-                <a:solidFill>
-                  <a:srgbClr val="F5F5F7"/>
-                </a:solidFill>
-                <a:latin typeface="Arial"/>
-                <a:ea typeface="Arial"/>
-              </a:rPr>
-              <a:t>CJK budgets</a:t>
-            </a:r>
-          </a:p>
-        </p:txBody>
-      </p:sp>
-      <p:sp>
-        <p:nvSpPr>
-          <p:cNvPr id="100045" name="Stair3"/>
-          <p:cNvSpPr/>
-          <p:nvPr/>
-        </p:nvSpPr>
-        <p:spPr>
-          <a:xfrm xmlns:a="http://schemas.openxmlformats.org/drawingml/2006/main">
-            <a:off x="5079600" y="3024000"/>
-            <a:ext cx="2034000" cy="3024000"/>
-          </a:xfrm>
-          <a:prstGeom xmlns:a="http://schemas.openxmlformats.org/drawingml/2006/main" prst="roundRect">
-            <a:avLst/>
-          </a:prstGeom>
-          <a:solidFill xmlns:a="http://schemas.openxmlformats.org/drawingml/2006/main">
-            <a:srgbClr val="1C1C1E"/>
-          </a:solidFill>
-          <a:ln xmlns:a="http://schemas.openxmlformats.org/drawingml/2006/main">
-            <a:noFill/>
-          </a:ln>
-        </p:spPr>
-        <p:txBody>
-          <a:bodyPr xmlns:a="http://schemas.openxmlformats.org/drawingml/2006/main" anchor="ctr"/>
-          <a:lstStyle xmlns:a="http://schemas.openxmlformats.org/drawingml/2006/main"/>
-          <a:p xmlns:a="http://schemas.openxmlformats.org/drawingml/2006/main">
-            <a:pPr algn="ctr"/>
-            <a:r>
-              <a:rPr lang="en-US" sz="1800" b="1">
-                <a:solidFill>
-                  <a:srgbClr val="F5F5F7"/>
-                </a:solidFill>
-                <a:latin typeface="Arial"/>
-                <a:ea typeface="Arial"/>
-              </a:rPr>
-              <a:t>3</a:t>
-            </a:r>
-          </a:p>
-          <a:p xmlns:a="http://schemas.openxmlformats.org/drawingml/2006/main">
-            <a:pPr algn="ctr"/>
-            <a:r>
-              <a:rPr lang="en-US" sz="1800" b="1">
-                <a:solidFill>
-                  <a:srgbClr val="F5F5F7"/>
-                </a:solidFill>
-                <a:latin typeface="Arial"/>
-                <a:ea typeface="Arial"/>
-              </a:rPr>
-              <a:t>Issues</a:t>
-            </a:r>
-          </a:p>
-          <a:p xmlns:a="http://schemas.openxmlformats.org/drawingml/2006/main">
-            <a:pPr algn="ctr"/>
-            <a:r>
-              <a:rPr lang="en-US" sz="1800" b="1">
-                <a:solidFill>
-                  <a:srgbClr val="F5F5F7"/>
-                </a:solidFill>
-                <a:latin typeface="Arial"/>
-                <a:ea typeface="Arial"/>
-              </a:rPr>
-              <a:t>Overlap gate</a:t>
-            </a:r>
-          </a:p>
-        </p:txBody>
-      </p:sp>
-      <p:sp>
-        <p:nvSpPr>
-          <p:cNvPr id="100046" name="Stair4"/>
-          <p:cNvSpPr/>
-          <p:nvPr/>
-        </p:nvSpPr>
-        <p:spPr>
-          <a:xfrm xmlns:a="http://schemas.openxmlformats.org/drawingml/2006/main">
-            <a:off x="7200000" y="2196000"/>
-            <a:ext cx="2034000" cy="3852000"/>
-          </a:xfrm>
-          <a:prstGeom xmlns:a="http://schemas.openxmlformats.org/drawingml/2006/main" prst="roundRect">
-            <a:avLst/>
-          </a:prstGeom>
-          <a:solidFill xmlns:a="http://schemas.openxmlformats.org/drawingml/2006/main">
-            <a:srgbClr val="1C1C1E"/>
-          </a:solidFill>
-          <a:ln xmlns:a="http://schemas.openxmlformats.org/drawingml/2006/main">
-            <a:noFill/>
-          </a:ln>
-        </p:spPr>
-        <p:txBody>
-          <a:bodyPr xmlns:a="http://schemas.openxmlformats.org/drawingml/2006/main" anchor="ctr"/>
-          <a:lstStyle xmlns:a="http://schemas.openxmlformats.org/drawingml/2006/main"/>
-          <a:p xmlns:a="http://schemas.openxmlformats.org/drawingml/2006/main">
-            <a:pPr algn="ctr"/>
-            <a:r>
-              <a:rPr lang="en-US" sz="1800" b="1">
-                <a:solidFill>
-                  <a:srgbClr val="F5F5F7"/>
-                </a:solidFill>
-                <a:latin typeface="Arial"/>
-                <a:ea typeface="Arial"/>
-              </a:rPr>
-              <a:t>4</a:t>
-            </a:r>
-          </a:p>
-          <a:p xmlns:a="http://schemas.openxmlformats.org/drawingml/2006/main">
-            <a:pPr algn="ctr"/>
-            <a:r>
-              <a:rPr lang="en-US" sz="1800" b="1">
-                <a:solidFill>
-                  <a:srgbClr val="F5F5F7"/>
-                </a:solidFill>
-                <a:latin typeface="Arial"/>
-                <a:ea typeface="Arial"/>
-              </a:rPr>
-              <a:t>Gate 3</a:t>
-            </a:r>
-          </a:p>
-          <a:p xmlns:a="http://schemas.openxmlformats.org/drawingml/2006/main">
-            <a:pPr algn="ctr"/>
-            <a:r>
-              <a:rPr lang="en-US" sz="1800" b="1">
-                <a:solidFill>
-                  <a:srgbClr val="F5F5F7"/>
-                </a:solidFill>
-                <a:latin typeface="Arial"/>
-                <a:ea typeface="Arial"/>
-              </a:rPr>
-              <a:t>Contact sheet</a:t>
-            </a:r>
-          </a:p>
-        </p:txBody>
-      </p:sp>
-      <p:sp>
-        <p:nvSpPr>
-          <p:cNvPr id="100047" name="Stair5"/>
-          <p:cNvSpPr/>
-          <p:nvPr/>
-        </p:nvSpPr>
-        <p:spPr>
-          <a:xfrm xmlns:a="http://schemas.openxmlformats.org/drawingml/2006/main">
-            <a:off x="9324000" y="1368000"/>
-            <a:ext cx="2034000" cy="4680000"/>
+            <a:off x="6292800" y="2196000"/>
+            <a:ext cx="5104800" cy="2448000"/>
           </a:xfrm>
           <a:prstGeom xmlns:a="http://schemas.openxmlformats.org/drawingml/2006/main" prst="roundRect">
             <a:avLst/>
@@ -3327,45 +3444,73 @@
           </a:ln>
         </p:spPr>
         <p:txBody>
-          <a:bodyPr xmlns:a="http://schemas.openxmlformats.org/drawingml/2006/main" anchor="ctr"/>
-          <a:lstStyle xmlns:a="http://schemas.openxmlformats.org/drawingml/2006/main"/>
-          <a:p xmlns:a="http://schemas.openxmlformats.org/drawingml/2006/main">
-            <a:pPr algn="ctr"/>
-            <a:r>
-              <a:rPr lang="en-US" sz="1800" b="1">
+          <a:bodyPr xmlns:a="http://schemas.openxmlformats.org/drawingml/2006/main"/>
+          <a:lstStyle xmlns:a="http://schemas.openxmlformats.org/drawingml/2006/main"/>
+          <a:p xmlns:a="http://schemas.openxmlformats.org/drawingml/2006/main"/>
+        </p:txBody>
+      </p:sp>
+      <p:sp>
+        <p:nvSpPr>
+          <p:cNvPr id="100047" name="MVLab2"/>
+          <p:cNvSpPr txBox="1"/>
+          <p:nvPr/>
+        </p:nvSpPr>
+        <p:spPr>
+          <a:xfrm xmlns:a="http://schemas.openxmlformats.org/drawingml/2006/main">
+            <a:off x="6692400" y="2592000"/>
+            <a:ext cx="4312800" cy="540000"/>
+          </a:xfrm>
+          <a:prstGeom xmlns:a="http://schemas.openxmlformats.org/drawingml/2006/main" prst="rect">
+            <a:avLst/>
+          </a:prstGeom>
+          <a:noFill xmlns:a="http://schemas.openxmlformats.org/drawingml/2006/main"/>
+        </p:spPr>
+        <p:txBody>
+          <a:bodyPr xmlns:a="http://schemas.openxmlformats.org/drawingml/2006/main"/>
+          <a:lstStyle xmlns:a="http://schemas.openxmlformats.org/drawingml/2006/main"/>
+          <a:p xmlns:a="http://schemas.openxmlformats.org/drawingml/2006/main">
+            <a:r>
+              <a:rPr lang="en-US" sz="2800" b="1">
                 <a:solidFill>
                   <a:srgbClr val="FFFFFF"/>
                 </a:solidFill>
                 <a:latin typeface="Arial"/>
                 <a:ea typeface="Arial"/>
               </a:rPr>
-              <a:t>5</a:t>
-            </a:r>
-          </a:p>
-          <a:p xmlns:a="http://schemas.openxmlformats.org/drawingml/2006/main">
-            <a:pPr algn="ctr"/>
-            <a:r>
-              <a:rPr lang="en-US" sz="1800" b="1">
+              <a:t>Vision</a:t>
+            </a:r>
+          </a:p>
+        </p:txBody>
+      </p:sp>
+      <p:sp>
+        <p:nvSpPr>
+          <p:cNvPr id="100048" name="MVBody2"/>
+          <p:cNvSpPr txBox="1"/>
+          <p:nvPr/>
+        </p:nvSpPr>
+        <p:spPr>
+          <a:xfrm xmlns:a="http://schemas.openxmlformats.org/drawingml/2006/main">
+            <a:off x="6692400" y="3355200"/>
+            <a:ext cx="4312800" cy="896400"/>
+          </a:xfrm>
+          <a:prstGeom xmlns:a="http://schemas.openxmlformats.org/drawingml/2006/main" prst="rect">
+            <a:avLst/>
+          </a:prstGeom>
+          <a:noFill xmlns:a="http://schemas.openxmlformats.org/drawingml/2006/main"/>
+        </p:spPr>
+        <p:txBody>
+          <a:bodyPr xmlns:a="http://schemas.openxmlformats.org/drawingml/2006/main"/>
+          <a:lstStyle xmlns:a="http://schemas.openxmlformats.org/drawingml/2006/main"/>
+          <a:p xmlns:a="http://schemas.openxmlformats.org/drawingml/2006/main">
+            <a:r>
+              <a:rPr lang="en-US" sz="1800">
                 <a:solidFill>
                   <a:srgbClr val="FFFFFF"/>
                 </a:solidFill>
                 <a:latin typeface="Arial"/>
                 <a:ea typeface="Arial"/>
               </a:rPr>
-              <a:t>Ship</a:t>
-            </a:r>
-          </a:p>
-          <a:p xmlns:a="http://schemas.openxmlformats.org/drawingml/2006/main">
-            <a:pPr algn="ctr"/>
-            <a:r>
-              <a:rPr lang="en-US" sz="1800" b="1">
-                <a:solidFill>
-                  <a:srgbClr val="FFFFFF"/>
-                </a:solidFill>
-                <a:latin typeface="Arial"/>
-                <a:ea typeface="Arial"/>
-              </a:rPr>
-              <a:t>Human check</a:t>
+              <a:t>Ship DESIGN.md-native slides without designers in the pixel loop.</a:t>
             </a:r>
           </a:p>
         </p:txBody>
@@ -3496,7 +3641,7 @@
       <p:grpSpPr/>
       <p:sp>
         <p:nvSpPr>
-          <p:cNvPr id="100048" name="CheckTitle"/>
+          <p:cNvPr id="100049" name="StairsTitle"/>
           <p:cNvSpPr txBox="1"/>
           <p:nvPr/>
         </p:nvSpPr>
@@ -3522,21 +3667,21 @@
                 <a:latin typeface="Arial"/>
                 <a:ea typeface="Arial"/>
               </a:rPr>
-              <a:t>Hard rules we keep</a:t>
-            </a:r>
-          </a:p>
-        </p:txBody>
-      </p:sp>
-      <p:sp>
-        <p:nvSpPr>
-          <p:cNvPr id="100049" name="CheckRow1"/>
+              <a:t>Quality is a staircase</a:t>
+            </a:r>
+          </a:p>
+        </p:txBody>
+      </p:sp>
+      <p:sp>
+        <p:nvSpPr>
+          <p:cNvPr id="100050" name="Stair1"/>
           <p:cNvSpPr/>
           <p:nvPr/>
         </p:nvSpPr>
         <p:spPr>
           <a:xfrm xmlns:a="http://schemas.openxmlformats.org/drawingml/2006/main">
-            <a:off x="792000" y="1296000"/>
-            <a:ext cx="10609200" cy="630000"/>
+            <a:off x="828000" y="3538800"/>
+            <a:ext cx="2048400" cy="1717200"/>
           </a:xfrm>
           <a:prstGeom xmlns:a="http://schemas.openxmlformats.org/drawingml/2006/main" prst="roundRect">
             <a:avLst/>
@@ -3552,29 +3697,56 @@
           <a:bodyPr xmlns:a="http://schemas.openxmlformats.org/drawingml/2006/main" anchor="ctr"/>
           <a:lstStyle xmlns:a="http://schemas.openxmlformats.org/drawingml/2006/main"/>
           <a:p xmlns:a="http://schemas.openxmlformats.org/drawingml/2006/main">
-            <a:r>
-              <a:rPr lang="en-US" sz="1800" b="0">
-                <a:solidFill>
-                  <a:srgbClr val="F5F5F7"/>
-                </a:solidFill>
-                <a:latin typeface="Arial"/>
-                <a:ea typeface="Arial"/>
-              </a:rPr>
-              <a:t>✓  Title ≥ 36pt · body ≥ 18pt</a:t>
-            </a:r>
-          </a:p>
-        </p:txBody>
-      </p:sp>
-      <p:sp>
-        <p:nvSpPr>
-          <p:cNvPr id="100050" name="CheckRow2"/>
+            <a:pPr algn="ctr"/>
+            <a:r>
+              <a:rPr lang="en-US" sz="1800" b="1">
+                <a:solidFill>
+                  <a:srgbClr val="F5F5F7"/>
+                </a:solidFill>
+                <a:latin typeface="Arial"/>
+                <a:ea typeface="Arial"/>
+              </a:rPr>
+              <a:t>1</a:t>
+            </a:r>
+          </a:p>
+          <a:p xmlns:a="http://schemas.openxmlformats.org/drawingml/2006/main">
+            <a:pPr algn="ctr"/>
+            <a:r>
+              <a:rPr lang="en-US" sz="1800" b="1">
+                <a:solidFill>
+                  <a:srgbClr val="F5F5F7"/>
+                </a:solidFill>
+                <a:latin typeface="Arial"/>
+                <a:ea typeface="Arial"/>
+              </a:rPr>
+              <a:t>Tokens</a:t>
+            </a:r>
+          </a:p>
+          <a:p xmlns:a="http://schemas.openxmlformats.org/drawingml/2006/main">
+            <a:pPr algn="ctr"/>
+            <a:r>
+              <a:rPr lang="en-US" sz="1800" b="1">
+                <a:solidFill>
+                  <a:srgbClr val="F5F5F7"/>
+                </a:solidFill>
+                <a:latin typeface="Arial"/>
+                <a:ea typeface="Arial"/>
+              </a:rPr>
+              <a:t>Brand floors</a:t>
+            </a:r>
+          </a:p>
+        </p:txBody>
+      </p:sp>
+      <p:sp>
+        <p:nvSpPr>
+          <p:cNvPr id="100051" name="Stair2"/>
           <p:cNvSpPr/>
           <p:nvPr/>
         </p:nvSpPr>
         <p:spPr>
           <a:xfrm xmlns:a="http://schemas.openxmlformats.org/drawingml/2006/main">
-            <a:off x="792000" y="1980000"/>
-            <a:ext cx="10609200" cy="630000"/>
+            <a:off x="2948400" y="3013200"/>
+            <a:ext cx="2048400" cy="2242800"/>
           </a:xfrm>
           <a:prstGeom xmlns:a="http://schemas.openxmlformats.org/drawingml/2006/main" prst="roundRect">
             <a:avLst/>
@@ -3590,29 +3762,56 @@
           <a:bodyPr xmlns:a="http://schemas.openxmlformats.org/drawingml/2006/main" anchor="ctr"/>
           <a:lstStyle xmlns:a="http://schemas.openxmlformats.org/drawingml/2006/main"/>
           <a:p xmlns:a="http://schemas.openxmlformats.org/drawingml/2006/main">
-            <a:r>
-              <a:rPr lang="en-US" sz="1800" b="0">
-                <a:solidFill>
-                  <a:srgbClr val="F5F5F7"/>
-                </a:solidFill>
-                <a:latin typeface="Arial"/>
-                <a:ea typeface="Arial"/>
-              </a:rPr>
-              <a:t>✓  Never shrink fonts to fit — split or cut</a:t>
-            </a:r>
-          </a:p>
-        </p:txBody>
-      </p:sp>
-      <p:sp>
-        <p:nvSpPr>
-          <p:cNvPr id="100051" name="CheckRow3"/>
+            <a:pPr algn="ctr"/>
+            <a:r>
+              <a:rPr lang="en-US" sz="1800" b="1">
+                <a:solidFill>
+                  <a:srgbClr val="F5F5F7"/>
+                </a:solidFill>
+                <a:latin typeface="Arial"/>
+                <a:ea typeface="Arial"/>
+              </a:rPr>
+              <a:t>2</a:t>
+            </a:r>
+          </a:p>
+          <a:p xmlns:a="http://schemas.openxmlformats.org/drawingml/2006/main">
+            <a:pPr algn="ctr"/>
+            <a:r>
+              <a:rPr lang="en-US" sz="1800" b="1">
+                <a:solidFill>
+                  <a:srgbClr val="F5F5F7"/>
+                </a:solidFill>
+                <a:latin typeface="Arial"/>
+                <a:ea typeface="Arial"/>
+              </a:rPr>
+              <a:t>Fit</a:t>
+            </a:r>
+          </a:p>
+          <a:p xmlns:a="http://schemas.openxmlformats.org/drawingml/2006/main">
+            <a:pPr algn="ctr"/>
+            <a:r>
+              <a:rPr lang="en-US" sz="1800" b="1">
+                <a:solidFill>
+                  <a:srgbClr val="F5F5F7"/>
+                </a:solidFill>
+                <a:latin typeface="Arial"/>
+                <a:ea typeface="Arial"/>
+              </a:rPr>
+              <a:t>CJK budgets</a:t>
+            </a:r>
+          </a:p>
+        </p:txBody>
+      </p:sp>
+      <p:sp>
+        <p:nvSpPr>
+          <p:cNvPr id="100052" name="Stair3"/>
           <p:cNvSpPr/>
           <p:nvPr/>
         </p:nvSpPr>
         <p:spPr>
           <a:xfrm xmlns:a="http://schemas.openxmlformats.org/drawingml/2006/main">
-            <a:off x="792000" y="2664000"/>
-            <a:ext cx="10609200" cy="630000"/>
+            <a:off x="5072400" y="2487600"/>
+            <a:ext cx="2048400" cy="2768400"/>
           </a:xfrm>
           <a:prstGeom xmlns:a="http://schemas.openxmlformats.org/drawingml/2006/main" prst="roundRect">
             <a:avLst/>
@@ -3628,29 +3827,56 @@
           <a:bodyPr xmlns:a="http://schemas.openxmlformats.org/drawingml/2006/main" anchor="ctr"/>
           <a:lstStyle xmlns:a="http://schemas.openxmlformats.org/drawingml/2006/main"/>
           <a:p xmlns:a="http://schemas.openxmlformats.org/drawingml/2006/main">
-            <a:r>
-              <a:rPr lang="en-US" sz="1800" b="0">
-                <a:solidFill>
-                  <a:srgbClr val="F5F5F7"/>
-                </a:solidFill>
-                <a:latin typeface="Arial"/>
-                <a:ea typeface="Arial"/>
-              </a:rPr>
-              <a:t>✓  Overwrite only with --force</a:t>
-            </a:r>
-          </a:p>
-        </p:txBody>
-      </p:sp>
-      <p:sp>
-        <p:nvSpPr>
-          <p:cNvPr id="100052" name="CheckRow4"/>
+            <a:pPr algn="ctr"/>
+            <a:r>
+              <a:rPr lang="en-US" sz="1800" b="1">
+                <a:solidFill>
+                  <a:srgbClr val="F5F5F7"/>
+                </a:solidFill>
+                <a:latin typeface="Arial"/>
+                <a:ea typeface="Arial"/>
+              </a:rPr>
+              <a:t>3</a:t>
+            </a:r>
+          </a:p>
+          <a:p xmlns:a="http://schemas.openxmlformats.org/drawingml/2006/main">
+            <a:pPr algn="ctr"/>
+            <a:r>
+              <a:rPr lang="en-US" sz="1800" b="1">
+                <a:solidFill>
+                  <a:srgbClr val="F5F5F7"/>
+                </a:solidFill>
+                <a:latin typeface="Arial"/>
+                <a:ea typeface="Arial"/>
+              </a:rPr>
+              <a:t>Issues</a:t>
+            </a:r>
+          </a:p>
+          <a:p xmlns:a="http://schemas.openxmlformats.org/drawingml/2006/main">
+            <a:pPr algn="ctr"/>
+            <a:r>
+              <a:rPr lang="en-US" sz="1800" b="1">
+                <a:solidFill>
+                  <a:srgbClr val="F5F5F7"/>
+                </a:solidFill>
+                <a:latin typeface="Arial"/>
+                <a:ea typeface="Arial"/>
+              </a:rPr>
+              <a:t>Overlap gate</a:t>
+            </a:r>
+          </a:p>
+        </p:txBody>
+      </p:sp>
+      <p:sp>
+        <p:nvSpPr>
+          <p:cNvPr id="100053" name="Stair4"/>
           <p:cNvSpPr/>
           <p:nvPr/>
         </p:nvSpPr>
         <p:spPr>
           <a:xfrm xmlns:a="http://schemas.openxmlformats.org/drawingml/2006/main">
-            <a:off x="792000" y="3348000"/>
-            <a:ext cx="10609200" cy="630000"/>
+            <a:off x="7192800" y="1962000"/>
+            <a:ext cx="2048400" cy="3294000"/>
           </a:xfrm>
           <a:prstGeom xmlns:a="http://schemas.openxmlformats.org/drawingml/2006/main" prst="roundRect">
             <a:avLst/>
@@ -3666,35 +3892,62 @@
           <a:bodyPr xmlns:a="http://schemas.openxmlformats.org/drawingml/2006/main" anchor="ctr"/>
           <a:lstStyle xmlns:a="http://schemas.openxmlformats.org/drawingml/2006/main"/>
           <a:p xmlns:a="http://schemas.openxmlformats.org/drawingml/2006/main">
-            <a:r>
-              <a:rPr lang="en-US" sz="1800" b="0">
-                <a:solidFill>
-                  <a:srgbClr val="F5F5F7"/>
-                </a:solidFill>
-                <a:latin typeface="Arial"/>
-                <a:ea typeface="Arial"/>
-              </a:rPr>
-              <a:t>✓  Finish apply with --screenshot</a:t>
-            </a:r>
-          </a:p>
-        </p:txBody>
-      </p:sp>
-      <p:sp>
-        <p:nvSpPr>
-          <p:cNvPr id="100053" name="CheckRow5"/>
+            <a:pPr algn="ctr"/>
+            <a:r>
+              <a:rPr lang="en-US" sz="1800" b="1">
+                <a:solidFill>
+                  <a:srgbClr val="F5F5F7"/>
+                </a:solidFill>
+                <a:latin typeface="Arial"/>
+                <a:ea typeface="Arial"/>
+              </a:rPr>
+              <a:t>4</a:t>
+            </a:r>
+          </a:p>
+          <a:p xmlns:a="http://schemas.openxmlformats.org/drawingml/2006/main">
+            <a:pPr algn="ctr"/>
+            <a:r>
+              <a:rPr lang="en-US" sz="1800" b="1">
+                <a:solidFill>
+                  <a:srgbClr val="F5F5F7"/>
+                </a:solidFill>
+                <a:latin typeface="Arial"/>
+                <a:ea typeface="Arial"/>
+              </a:rPr>
+              <a:t>Gate 3</a:t>
+            </a:r>
+          </a:p>
+          <a:p xmlns:a="http://schemas.openxmlformats.org/drawingml/2006/main">
+            <a:pPr algn="ctr"/>
+            <a:r>
+              <a:rPr lang="en-US" sz="1800" b="1">
+                <a:solidFill>
+                  <a:srgbClr val="F5F5F7"/>
+                </a:solidFill>
+                <a:latin typeface="Arial"/>
+                <a:ea typeface="Arial"/>
+              </a:rPr>
+              <a:t>Contact sheet</a:t>
+            </a:r>
+          </a:p>
+        </p:txBody>
+      </p:sp>
+      <p:sp>
+        <p:nvSpPr>
+          <p:cNvPr id="100054" name="Stair5"/>
           <p:cNvSpPr/>
           <p:nvPr/>
         </p:nvSpPr>
         <p:spPr>
           <a:xfrm xmlns:a="http://schemas.openxmlformats.org/drawingml/2006/main">
-            <a:off x="792000" y="4032000"/>
-            <a:ext cx="10609200" cy="630000"/>
+            <a:off x="9316800" y="1436400"/>
+            <a:ext cx="2048400" cy="3816000"/>
           </a:xfrm>
           <a:prstGeom xmlns:a="http://schemas.openxmlformats.org/drawingml/2006/main" prst="roundRect">
             <a:avLst/>
           </a:prstGeom>
           <a:solidFill xmlns:a="http://schemas.openxmlformats.org/drawingml/2006/main">
-            <a:srgbClr val="1C1C1E"/>
+            <a:srgbClr val="0B5FFF"/>
           </a:solidFill>
           <a:ln xmlns:a="http://schemas.openxmlformats.org/drawingml/2006/main">
             <a:noFill/>
@@ -3704,15 +3957,42 @@
           <a:bodyPr xmlns:a="http://schemas.openxmlformats.org/drawingml/2006/main" anchor="ctr"/>
           <a:lstStyle xmlns:a="http://schemas.openxmlformats.org/drawingml/2006/main"/>
           <a:p xmlns:a="http://schemas.openxmlformats.org/drawingml/2006/main">
-            <a:r>
-              <a:rPr lang="en-US" sz="1800" b="0">
-                <a:solidFill>
-                  <a:srgbClr val="F5F5F7"/>
-                </a:solidFill>
-                <a:latin typeface="Arial"/>
-                <a:ea typeface="Arial"/>
-              </a:rPr>
-              <a:t>✓  Ask before installing OfficeCLI</a:t>
+            <a:pPr algn="ctr"/>
+            <a:r>
+              <a:rPr lang="en-US" sz="1800" b="1">
+                <a:solidFill>
+                  <a:srgbClr val="FFFFFF"/>
+                </a:solidFill>
+                <a:latin typeface="Arial"/>
+                <a:ea typeface="Arial"/>
+              </a:rPr>
+              <a:t>5</a:t>
+            </a:r>
+          </a:p>
+          <a:p xmlns:a="http://schemas.openxmlformats.org/drawingml/2006/main">
+            <a:pPr algn="ctr"/>
+            <a:r>
+              <a:rPr lang="en-US" sz="1800" b="1">
+                <a:solidFill>
+                  <a:srgbClr val="FFFFFF"/>
+                </a:solidFill>
+                <a:latin typeface="Arial"/>
+                <a:ea typeface="Arial"/>
+              </a:rPr>
+              <a:t>Ship</a:t>
+            </a:r>
+          </a:p>
+          <a:p xmlns:a="http://schemas.openxmlformats.org/drawingml/2006/main">
+            <a:pPr algn="ctr"/>
+            <a:r>
+              <a:rPr lang="en-US" sz="1800" b="1">
+                <a:solidFill>
+                  <a:srgbClr val="FFFFFF"/>
+                </a:solidFill>
+                <a:latin typeface="Arial"/>
+                <a:ea typeface="Arial"/>
+              </a:rPr>
+              <a:t>Human check</a:t>
             </a:r>
           </a:p>
         </p:txBody>
@@ -3752,7 +4032,7 @@
                                       <p:cBhvr>
                                         <p:cTn id="6" dur="500"/>
                                         <p:tgtEl>
-                                          <p:spTgt spid="100048"/>
+                                          <p:spTgt spid="100049"/>
                                         </p:tgtEl>
                                       </p:cBhvr>
                                     </p:animEffect>
@@ -3769,7 +4049,7 @@
                                       <p:cBhvr>
                                         <p:cTn id="8" dur="500"/>
                                         <p:tgtEl>
-                                          <p:spTgt spid="100049"/>
+                                          <p:spTgt spid="100050"/>
                                         </p:tgtEl>
                                       </p:cBhvr>
                                     </p:animEffect>
@@ -3786,7 +4066,7 @@
                                       <p:cBhvr>
                                         <p:cTn id="10" dur="500"/>
                                         <p:tgtEl>
-                                          <p:spTgt spid="100050"/>
+                                          <p:spTgt spid="100051"/>
                                         </p:tgtEl>
                                       </p:cBhvr>
                                     </p:animEffect>
@@ -3843,14 +4123,14 @@
       <p:grpSpPr/>
       <p:sp>
         <p:nvSpPr>
-          <p:cNvPr id="100054" name="CloseTitle"/>
+          <p:cNvPr id="100055" name="CheckTitle"/>
           <p:cNvSpPr txBox="1"/>
           <p:nvPr/>
         </p:nvSpPr>
         <p:spPr>
           <a:xfrm xmlns:a="http://schemas.openxmlformats.org/drawingml/2006/main">
-            <a:off x="792000" y="1796400"/>
-            <a:ext cx="10609200" cy="936000"/>
+            <a:off x="792000" y="435600"/>
+            <a:ext cx="10609200" cy="558000"/>
           </a:xfrm>
           <a:prstGeom xmlns:a="http://schemas.openxmlformats.org/drawingml/2006/main" prst="rect">
             <a:avLst/>
@@ -3861,70 +4141,35 @@
           <a:bodyPr xmlns:a="http://schemas.openxmlformats.org/drawingml/2006/main"/>
           <a:lstStyle xmlns:a="http://schemas.openxmlformats.org/drawingml/2006/main"/>
           <a:p xmlns:a="http://schemas.openxmlformats.org/drawingml/2006/main">
-            <a:pPr algn="ctr"/>
-            <a:r>
-              <a:rPr lang="en-US" sz="4400" b="1">
-                <a:solidFill>
-                  <a:srgbClr val="F5F5F7"/>
-                </a:solidFill>
-                <a:latin typeface="Arial"/>
-                <a:ea typeface="Arial"/>
-              </a:rPr>
-              <a:t>Start with the brand file</a:t>
-            </a:r>
-          </a:p>
-        </p:txBody>
-      </p:sp>
-      <p:sp>
-        <p:nvSpPr>
-          <p:cNvPr id="100055" name="CloseBody"/>
-          <p:cNvSpPr txBox="1"/>
-          <p:nvPr/>
-        </p:nvSpPr>
-        <p:spPr>
-          <a:xfrm xmlns:a="http://schemas.openxmlformats.org/drawingml/2006/main">
-            <a:off x="1188000" y="2952000"/>
-            <a:ext cx="9817200" cy="720000"/>
-          </a:xfrm>
-          <a:prstGeom xmlns:a="http://schemas.openxmlformats.org/drawingml/2006/main" prst="rect">
-            <a:avLst/>
-          </a:prstGeom>
-          <a:noFill xmlns:a="http://schemas.openxmlformats.org/drawingml/2006/main"/>
-        </p:spPr>
-        <p:txBody>
-          <a:bodyPr xmlns:a="http://schemas.openxmlformats.org/drawingml/2006/main"/>
-          <a:lstStyle xmlns:a="http://schemas.openxmlformats.org/drawingml/2006/main"/>
-          <a:p xmlns:a="http://schemas.openxmlformats.org/drawingml/2006/main">
-            <a:pPr algn="ctr"/>
-            <a:r>
-              <a:rPr lang="en-US" sz="1800">
-                <a:solidFill>
-                  <a:srgbClr val="A0A6B0"/>
-                </a:solidFill>
-                <a:latin typeface="Arial"/>
-                <a:ea typeface="Arial"/>
-              </a:rPr>
-              <a:t>doctor --ensure · compose a brief · scaffold · apply --screenshot</a:t>
-            </a:r>
-          </a:p>
-        </p:txBody>
-      </p:sp>
-      <p:sp>
-        <p:nvSpPr>
-          <p:cNvPr id="100056" name="CloseCta"/>
+            <a:r>
+              <a:rPr lang="en-US" sz="3600" b="1">
+                <a:solidFill>
+                  <a:srgbClr val="F5F5F7"/>
+                </a:solidFill>
+                <a:latin typeface="Arial"/>
+                <a:ea typeface="Arial"/>
+              </a:rPr>
+              <a:t>Hard rules</a:t>
+            </a:r>
+          </a:p>
+        </p:txBody>
+      </p:sp>
+      <p:sp>
+        <p:nvSpPr>
+          <p:cNvPr id="100056" name="CheckRow1"/>
           <p:cNvSpPr/>
           <p:nvPr/>
         </p:nvSpPr>
         <p:spPr>
           <a:xfrm xmlns:a="http://schemas.openxmlformats.org/drawingml/2006/main">
-            <a:off x="4294800" y="4068000"/>
-            <a:ext cx="3600000" cy="612000"/>
+            <a:off x="792000" y="1533600"/>
+            <a:ext cx="10609200" cy="651600"/>
           </a:xfrm>
           <a:prstGeom xmlns:a="http://schemas.openxmlformats.org/drawingml/2006/main" prst="roundRect">
             <a:avLst/>
           </a:prstGeom>
           <a:solidFill xmlns:a="http://schemas.openxmlformats.org/drawingml/2006/main">
-            <a:srgbClr val="0B5FFF"/>
+            <a:srgbClr val="1C1C1E"/>
           </a:solidFill>
           <a:ln xmlns:a="http://schemas.openxmlformats.org/drawingml/2006/main">
             <a:noFill/>
@@ -3934,16 +4179,167 @@
           <a:bodyPr xmlns:a="http://schemas.openxmlformats.org/drawingml/2006/main" anchor="ctr"/>
           <a:lstStyle xmlns:a="http://schemas.openxmlformats.org/drawingml/2006/main"/>
           <a:p xmlns:a="http://schemas.openxmlformats.org/drawingml/2006/main">
-            <a:pPr algn="ctr"/>
-            <a:r>
-              <a:rPr lang="en-US" sz="1800" b="1">
-                <a:solidFill>
-                  <a:srgbClr val="FFFFFF"/>
-                </a:solidFill>
-                <a:latin typeface="Arial"/>
-                <a:ea typeface="Arial"/>
-              </a:rPr>
-              <a:t>doctor --ensure</a:t>
+            <a:r>
+              <a:rPr lang="en-US" sz="1800" b="0">
+                <a:solidFill>
+                  <a:srgbClr val="F5F5F7"/>
+                </a:solidFill>
+                <a:latin typeface="Arial"/>
+                <a:ea typeface="Arial"/>
+              </a:rPr>
+              <a:t>✓  Title ≥ 36pt · body ≥ 18pt</a:t>
+            </a:r>
+          </a:p>
+        </p:txBody>
+      </p:sp>
+      <p:sp>
+        <p:nvSpPr>
+          <p:cNvPr id="100057" name="CheckRow2"/>
+          <p:cNvSpPr/>
+          <p:nvPr/>
+        </p:nvSpPr>
+        <p:spPr>
+          <a:xfrm xmlns:a="http://schemas.openxmlformats.org/drawingml/2006/main">
+            <a:off x="792000" y="2250000"/>
+            <a:ext cx="10609200" cy="651600"/>
+          </a:xfrm>
+          <a:prstGeom xmlns:a="http://schemas.openxmlformats.org/drawingml/2006/main" prst="roundRect">
+            <a:avLst/>
+          </a:prstGeom>
+          <a:solidFill xmlns:a="http://schemas.openxmlformats.org/drawingml/2006/main">
+            <a:srgbClr val="1C1C1E"/>
+          </a:solidFill>
+          <a:ln xmlns:a="http://schemas.openxmlformats.org/drawingml/2006/main">
+            <a:noFill/>
+          </a:ln>
+        </p:spPr>
+        <p:txBody>
+          <a:bodyPr xmlns:a="http://schemas.openxmlformats.org/drawingml/2006/main" anchor="ctr"/>
+          <a:lstStyle xmlns:a="http://schemas.openxmlformats.org/drawingml/2006/main"/>
+          <a:p xmlns:a="http://schemas.openxmlformats.org/drawingml/2006/main">
+            <a:r>
+              <a:rPr lang="en-US" sz="1800" b="0">
+                <a:solidFill>
+                  <a:srgbClr val="F5F5F7"/>
+                </a:solidFill>
+                <a:latin typeface="Arial"/>
+                <a:ea typeface="Arial"/>
+              </a:rPr>
+              <a:t>✓  Never shrink fonts to fit — split or cut</a:t>
+            </a:r>
+          </a:p>
+        </p:txBody>
+      </p:sp>
+      <p:sp>
+        <p:nvSpPr>
+          <p:cNvPr id="100058" name="CheckRow3"/>
+          <p:cNvSpPr/>
+          <p:nvPr/>
+        </p:nvSpPr>
+        <p:spPr>
+          <a:xfrm xmlns:a="http://schemas.openxmlformats.org/drawingml/2006/main">
+            <a:off x="792000" y="2962800"/>
+            <a:ext cx="10609200" cy="651600"/>
+          </a:xfrm>
+          <a:prstGeom xmlns:a="http://schemas.openxmlformats.org/drawingml/2006/main" prst="roundRect">
+            <a:avLst/>
+          </a:prstGeom>
+          <a:solidFill xmlns:a="http://schemas.openxmlformats.org/drawingml/2006/main">
+            <a:srgbClr val="1C1C1E"/>
+          </a:solidFill>
+          <a:ln xmlns:a="http://schemas.openxmlformats.org/drawingml/2006/main">
+            <a:noFill/>
+          </a:ln>
+        </p:spPr>
+        <p:txBody>
+          <a:bodyPr xmlns:a="http://schemas.openxmlformats.org/drawingml/2006/main" anchor="ctr"/>
+          <a:lstStyle xmlns:a="http://schemas.openxmlformats.org/drawingml/2006/main"/>
+          <a:p xmlns:a="http://schemas.openxmlformats.org/drawingml/2006/main">
+            <a:r>
+              <a:rPr lang="en-US" sz="1800" b="0">
+                <a:solidFill>
+                  <a:srgbClr val="F5F5F7"/>
+                </a:solidFill>
+                <a:latin typeface="Arial"/>
+                <a:ea typeface="Arial"/>
+              </a:rPr>
+              <a:t>✓  Body height follows content, not free space</a:t>
+            </a:r>
+          </a:p>
+        </p:txBody>
+      </p:sp>
+      <p:sp>
+        <p:nvSpPr>
+          <p:cNvPr id="100059" name="CheckRow4"/>
+          <p:cNvSpPr/>
+          <p:nvPr/>
+        </p:nvSpPr>
+        <p:spPr>
+          <a:xfrm xmlns:a="http://schemas.openxmlformats.org/drawingml/2006/main">
+            <a:off x="792000" y="3679200"/>
+            <a:ext cx="10609200" cy="651600"/>
+          </a:xfrm>
+          <a:prstGeom xmlns:a="http://schemas.openxmlformats.org/drawingml/2006/main" prst="roundRect">
+            <a:avLst/>
+          </a:prstGeom>
+          <a:solidFill xmlns:a="http://schemas.openxmlformats.org/drawingml/2006/main">
+            <a:srgbClr val="1C1C1E"/>
+          </a:solidFill>
+          <a:ln xmlns:a="http://schemas.openxmlformats.org/drawingml/2006/main">
+            <a:noFill/>
+          </a:ln>
+        </p:spPr>
+        <p:txBody>
+          <a:bodyPr xmlns:a="http://schemas.openxmlformats.org/drawingml/2006/main" anchor="ctr"/>
+          <a:lstStyle xmlns:a="http://schemas.openxmlformats.org/drawingml/2006/main"/>
+          <a:p xmlns:a="http://schemas.openxmlformats.org/drawingml/2006/main">
+            <a:r>
+              <a:rPr lang="en-US" sz="1800" b="0">
+                <a:solidFill>
+                  <a:srgbClr val="F5F5F7"/>
+                </a:solidFill>
+                <a:latin typeface="Arial"/>
+                <a:ea typeface="Arial"/>
+              </a:rPr>
+              <a:t>✓  Overwrite only with --force</a:t>
+            </a:r>
+          </a:p>
+        </p:txBody>
+      </p:sp>
+      <p:sp>
+        <p:nvSpPr>
+          <p:cNvPr id="100060" name="CheckRow5"/>
+          <p:cNvSpPr/>
+          <p:nvPr/>
+        </p:nvSpPr>
+        <p:spPr>
+          <a:xfrm xmlns:a="http://schemas.openxmlformats.org/drawingml/2006/main">
+            <a:off x="792000" y="4395600"/>
+            <a:ext cx="10609200" cy="651600"/>
+          </a:xfrm>
+          <a:prstGeom xmlns:a="http://schemas.openxmlformats.org/drawingml/2006/main" prst="roundRect">
+            <a:avLst/>
+          </a:prstGeom>
+          <a:solidFill xmlns:a="http://schemas.openxmlformats.org/drawingml/2006/main">
+            <a:srgbClr val="1C1C1E"/>
+          </a:solidFill>
+          <a:ln xmlns:a="http://schemas.openxmlformats.org/drawingml/2006/main">
+            <a:noFill/>
+          </a:ln>
+        </p:spPr>
+        <p:txBody>
+          <a:bodyPr xmlns:a="http://schemas.openxmlformats.org/drawingml/2006/main" anchor="ctr"/>
+          <a:lstStyle xmlns:a="http://schemas.openxmlformats.org/drawingml/2006/main"/>
+          <a:p xmlns:a="http://schemas.openxmlformats.org/drawingml/2006/main">
+            <a:r>
+              <a:rPr lang="en-US" sz="1800" b="0">
+                <a:solidFill>
+                  <a:srgbClr val="F5F5F7"/>
+                </a:solidFill>
+                <a:latin typeface="Arial"/>
+                <a:ea typeface="Arial"/>
+              </a:rPr>
+              <a:t>✓  Finish apply with --screenshot</a:t>
             </a:r>
           </a:p>
         </p:txBody>
@@ -3983,7 +4379,7 @@
                                       <p:cBhvr>
                                         <p:cTn id="6" dur="500"/>
                                         <p:tgtEl>
-                                          <p:spTgt spid="100054"/>
+                                          <p:spTgt spid="100055"/>
                                         </p:tgtEl>
                                       </p:cBhvr>
                                     </p:animEffect>
@@ -4000,7 +4396,7 @@
                                       <p:cBhvr>
                                         <p:cTn id="8" dur="500"/>
                                         <p:tgtEl>
-                                          <p:spTgt spid="100055"/>
+                                          <p:spTgt spid="100056"/>
                                         </p:tgtEl>
                                       </p:cBhvr>
                                     </p:animEffect>
@@ -4017,7 +4413,7 @@
                                       <p:cBhvr>
                                         <p:cTn id="10" dur="500"/>
                                         <p:tgtEl>
-                                          <p:spTgt spid="100056"/>
+                                          <p:spTgt spid="100057"/>
                                         </p:tgtEl>
                                       </p:cBhvr>
                                     </p:animEffect>

</xml_diff>